<commit_message>
AutomaTivio: relatório fiel ao publicado de agosto/2026, taxas dos ALT e PDF selecionável
- Folha A4 redesenhada sobre os PDFs publicados (Institucional 30 e ALT 180):
  cabeçalho preto com logo horizontal e o T, painel do topo, barras e rating
  no desenho do original, histórico desde o início, comentário, mercado de
  crédito, características em duas colunas, disclaimer e rodapé.
- Treemap da alocação real com legenda.
- Taxas e performance dos ALT 180, 90 e Light pelo relatório publicado
  (configs/fundos.yml vence a taxas_global.xlsx).
- PDF: conferência pós-geração (páginas, A4, texto selecionável) e comando
  avulso `python -m exporters.pdf`, no padrão da skill html-to-pdf. O botão
  "PDF (baixar)" da página ganha camada de texto selecionável.
- Saída de agosto/2026 regenerada.

Co-Authored-By: Claude Opus 5.5 <noreply@anthropic.com>
</commit_message>
<xml_diff>
--- a/AutomaTivio/saida/2026-08/pptx/Tivio ALT 180 - Relatório de Gestão - Agosto 2026.pptx
+++ b/AutomaTivio/saida/2026-08/pptx/Tivio ALT 180 - Relatório de Gestão - Agosto 2026.pptx
@@ -6530,7 +6530,7 @@
                           </a:solidFill>
                           <a:latin typeface="Versos"/>
                         </a:rPr>
-                        <a:t>Investidores em geral</a:t>
+                        <a:t>Investidores qualificados, Family Offices e Multi Family</a:t>
                       </a:r>
                     </a:p>
                   </a:txBody>
@@ -6818,7 +6818,7 @@
                           </a:solidFill>
                           <a:latin typeface="Versos"/>
                         </a:rPr>
-                        <a:t>−</a:t>
+                        <a:t>20% do que exceder do CDI</a:t>
                       </a:r>
                     </a:p>
                   </a:txBody>
@@ -6938,6 +6938,259 @@
         <p:spPr>
           <a:xfrm>
             <a:off x="540000" y="3744000"/>
+            <a:ext cx="4320000" cy="180000"/>
+          </a:xfrm>
+          <a:prstGeom prst="rect">
+            <a:avLst/>
+          </a:prstGeom>
+          <a:noFill/>
+        </p:spPr>
+        <p:txBody>
+          <a:bodyPr wrap="square" lIns="0" rIns="0" tIns="0" bIns="0">
+            <a:spAutoFit/>
+          </a:bodyPr>
+          <a:lstStyle/>
+          <a:p>
+            <a:pPr algn="l"/>
+            <a:r>
+              <a:rPr sz="900" b="1">
+                <a:solidFill>
+                  <a:srgbClr val="759DB4"/>
+                </a:solidFill>
+                <a:latin typeface="Versos"/>
+              </a:rPr>
+              <a:t>INFORMAÇÕES OPERACIONAIS</a:t>
+            </a:r>
+          </a:p>
+        </p:txBody>
+      </p:sp>
+      <p:graphicFrame>
+        <p:nvGraphicFramePr>
+          <p:cNvPr id="9" name="Table 8"/>
+          <p:cNvGraphicFramePr>
+            <a:graphicFrameLocks noGrp="1"/>
+          </p:cNvGraphicFramePr>
+          <p:nvPr/>
+        </p:nvGraphicFramePr>
+        <p:xfrm>
+          <a:off x="540000" y="3942000"/>
+          <a:ext cx="6479999" cy="748800"/>
+        </p:xfrm>
+        <a:graphic>
+          <a:graphicData uri="http://schemas.openxmlformats.org/drawingml/2006/table">
+            <a:tbl>
+              <a:tblPr firstRow="1" bandRow="1">
+                <a:tableStyleId>{5C22544A-7EE6-4342-B048-85BDC9FD1C3A}</a:tableStyleId>
+              </a:tblPr>
+              <a:tblGrid>
+                <a:gridCol w="3751578"/>
+                <a:gridCol w="2728421"/>
+              </a:tblGrid>
+              <a:tr h="187200">
+                <a:tc>
+                  <a:txBody>
+                    <a:bodyPr/>
+                    <a:lstStyle/>
+                    <a:p>
+                      <a:pPr algn="l"/>
+                      <a:r>
+                        <a:rPr sz="850" b="1">
+                          <a:solidFill>
+                            <a:srgbClr val="1A1A1A"/>
+                          </a:solidFill>
+                          <a:latin typeface="Versos"/>
+                        </a:rPr>
+                        <a:t>Aplicação</a:t>
+                      </a:r>
+                    </a:p>
+                  </a:txBody>
+                  <a:tcPr marL="43200" marR="43200" marT="0" marB="0">
+                    <a:solidFill>
+                      <a:srgbClr val="FFFFFF"/>
+                    </a:solidFill>
+                  </a:tcPr>
+                </a:tc>
+                <a:tc>
+                  <a:txBody>
+                    <a:bodyPr/>
+                    <a:lstStyle/>
+                    <a:p>
+                      <a:pPr algn="r"/>
+                      <a:r>
+                        <a:rPr sz="850" b="0">
+                          <a:solidFill>
+                            <a:srgbClr val="1A1A1A"/>
+                          </a:solidFill>
+                          <a:latin typeface="Versos"/>
+                        </a:rPr>
+                        <a:t>D+1</a:t>
+                      </a:r>
+                    </a:p>
+                  </a:txBody>
+                  <a:tcPr marL="43200" marR="43200" marT="0" marB="0">
+                    <a:solidFill>
+                      <a:srgbClr val="FFFFFF"/>
+                    </a:solidFill>
+                  </a:tcPr>
+                </a:tc>
+              </a:tr>
+              <a:tr h="187200">
+                <a:tc>
+                  <a:txBody>
+                    <a:bodyPr/>
+                    <a:lstStyle/>
+                    <a:p>
+                      <a:pPr algn="l"/>
+                      <a:r>
+                        <a:rPr sz="850" b="1">
+                          <a:solidFill>
+                            <a:srgbClr val="1A1A1A"/>
+                          </a:solidFill>
+                          <a:latin typeface="Versos"/>
+                        </a:rPr>
+                        <a:t>Resgate</a:t>
+                      </a:r>
+                    </a:p>
+                  </a:txBody>
+                  <a:tcPr marL="43200" marR="43200" marT="0" marB="0">
+                    <a:solidFill>
+                      <a:srgbClr val="F4F7F9"/>
+                    </a:solidFill>
+                  </a:tcPr>
+                </a:tc>
+                <a:tc>
+                  <a:txBody>
+                    <a:bodyPr/>
+                    <a:lstStyle/>
+                    <a:p>
+                      <a:pPr algn="r"/>
+                      <a:r>
+                        <a:rPr sz="850" b="0">
+                          <a:solidFill>
+                            <a:srgbClr val="1A1A1A"/>
+                          </a:solidFill>
+                          <a:latin typeface="Versos"/>
+                        </a:rPr>
+                        <a:t>D+180</a:t>
+                      </a:r>
+                    </a:p>
+                  </a:txBody>
+                  <a:tcPr marL="43200" marR="43200" marT="0" marB="0">
+                    <a:solidFill>
+                      <a:srgbClr val="F4F7F9"/>
+                    </a:solidFill>
+                  </a:tcPr>
+                </a:tc>
+              </a:tr>
+              <a:tr h="187200">
+                <a:tc>
+                  <a:txBody>
+                    <a:bodyPr/>
+                    <a:lstStyle/>
+                    <a:p>
+                      <a:pPr algn="l"/>
+                      <a:r>
+                        <a:rPr sz="850" b="1">
+                          <a:solidFill>
+                            <a:srgbClr val="1A1A1A"/>
+                          </a:solidFill>
+                          <a:latin typeface="Versos"/>
+                        </a:rPr>
+                        <a:t>Aplicação mínima inicial</a:t>
+                      </a:r>
+                    </a:p>
+                  </a:txBody>
+                  <a:tcPr marL="43200" marR="43200" marT="0" marB="0">
+                    <a:solidFill>
+                      <a:srgbClr val="FFFFFF"/>
+                    </a:solidFill>
+                  </a:tcPr>
+                </a:tc>
+                <a:tc>
+                  <a:txBody>
+                    <a:bodyPr/>
+                    <a:lstStyle/>
+                    <a:p>
+                      <a:pPr algn="r"/>
+                      <a:r>
+                        <a:rPr sz="850" b="0">
+                          <a:solidFill>
+                            <a:srgbClr val="1A1A1A"/>
+                          </a:solidFill>
+                          <a:latin typeface="Versos"/>
+                        </a:rPr>
+                        <a:t>R$ 1.000,00</a:t>
+                      </a:r>
+                    </a:p>
+                  </a:txBody>
+                  <a:tcPr marL="43200" marR="43200" marT="0" marB="0">
+                    <a:solidFill>
+                      <a:srgbClr val="FFFFFF"/>
+                    </a:solidFill>
+                  </a:tcPr>
+                </a:tc>
+              </a:tr>
+              <a:tr h="187200">
+                <a:tc>
+                  <a:txBody>
+                    <a:bodyPr/>
+                    <a:lstStyle/>
+                    <a:p>
+                      <a:pPr algn="l"/>
+                      <a:r>
+                        <a:rPr sz="850" b="1">
+                          <a:solidFill>
+                            <a:srgbClr val="1A1A1A"/>
+                          </a:solidFill>
+                          <a:latin typeface="Versos"/>
+                        </a:rPr>
+                        <a:t>Movimentação mínima</a:t>
+                      </a:r>
+                    </a:p>
+                  </a:txBody>
+                  <a:tcPr marL="43200" marR="43200" marT="0" marB="0">
+                    <a:solidFill>
+                      <a:srgbClr val="F4F7F9"/>
+                    </a:solidFill>
+                  </a:tcPr>
+                </a:tc>
+                <a:tc>
+                  <a:txBody>
+                    <a:bodyPr/>
+                    <a:lstStyle/>
+                    <a:p>
+                      <a:pPr algn="r"/>
+                      <a:r>
+                        <a:rPr sz="850" b="0">
+                          <a:solidFill>
+                            <a:srgbClr val="1A1A1A"/>
+                          </a:solidFill>
+                          <a:latin typeface="Versos"/>
+                        </a:rPr>
+                        <a:t>R$ 1.000,00</a:t>
+                      </a:r>
+                    </a:p>
+                  </a:txBody>
+                  <a:tcPr marL="43200" marR="43200" marT="0" marB="0">
+                    <a:solidFill>
+                      <a:srgbClr val="F4F7F9"/>
+                    </a:solidFill>
+                  </a:tcPr>
+                </a:tc>
+              </a:tr>
+            </a:tbl>
+          </a:graphicData>
+        </a:graphic>
+      </p:graphicFrame>
+      <p:sp>
+        <p:nvSpPr>
+          <p:cNvPr id="10" name="TextBox 9"/>
+          <p:cNvSpPr txBox="1"/>
+          <p:nvPr/>
+        </p:nvSpPr>
+        <p:spPr>
+          <a:xfrm>
+            <a:off x="540000" y="4978800"/>
             <a:ext cx="6480000" cy="180000"/>
           </a:xfrm>
           <a:prstGeom prst="rect">
@@ -6966,14 +7219,14 @@
       </p:sp>
       <p:sp>
         <p:nvSpPr>
-          <p:cNvPr id="9" name="TextBox 8"/>
+          <p:cNvPr id="11" name="TextBox 10"/>
           <p:cNvSpPr txBox="1"/>
           <p:nvPr/>
         </p:nvSpPr>
         <p:spPr>
           <a:xfrm>
-            <a:off x="540000" y="3942000"/>
-            <a:ext cx="6480000" cy="6156000"/>
+            <a:off x="540000" y="5176800"/>
+            <a:ext cx="6480000" cy="4921200"/>
           </a:xfrm>
           <a:prstGeom prst="rect">
             <a:avLst/>
@@ -7073,7 +7326,7 @@
       </p:sp>
       <p:sp>
         <p:nvSpPr>
-          <p:cNvPr id="10" name="TextBox 9"/>
+          <p:cNvPr id="12" name="TextBox 11"/>
           <p:cNvSpPr txBox="1"/>
           <p:nvPr/>
         </p:nvSpPr>
@@ -7108,7 +7361,7 @@
       </p:sp>
       <p:sp>
         <p:nvSpPr>
-          <p:cNvPr id="11" name="TextBox 10"/>
+          <p:cNvPr id="13" name="TextBox 12"/>
           <p:cNvSpPr txBox="1"/>
           <p:nvPr/>
         </p:nvSpPr>

</xml_diff>

<commit_message>
AutomaTivio: ALT Light no desenho do relatório publicado
- ALT Light: razão social "TIVIO ALT LIGHT XP PREV", paleta própria no
  treemap (treemap_cores), 15 setores em linhas compactas com valor em azul
  (setores_max_relatorio, estrategia_linha).
- Caixa "Rentabilidade CDI +": período sem número (fundo sem 12M) sai.
- Gráfico do Estruturado: grade até o degrau abaixo do valor final, com
  folga para a linha e a etiqueta; mês de início parcial sem rótulo e a
  linha nascendo em 0 (vale para ALT 180, 90 e Light, como os publicados).

Co-Authored-By: Claude Opus 5.5 <noreply@anthropic.com>
</commit_message>
<xml_diff>
--- a/AutomaTivio/saida/2026-08/pptx/Tivio ALT 180 - Relatório de Gestão - Agosto 2026.pptx
+++ b/AutomaTivio/saida/2026-08/pptx/Tivio ALT 180 - Relatório de Gestão - Agosto 2026.pptx
@@ -6948,8 +6948,8 @@
         </p:nvSpPr>
         <p:spPr>
           <a:xfrm>
-            <a:off x="551880" y="5430915"/>
-            <a:ext cx="3302208" cy="151200"/>
+            <a:off x="551880" y="5476275"/>
+            <a:ext cx="3066336" cy="151200"/>
           </a:xfrm>
           <a:prstGeom prst="rect">
             <a:avLst/>
@@ -6985,8 +6985,8 @@
         </p:nvSpPr>
         <p:spPr>
           <a:xfrm>
-            <a:off x="551880" y="5748435"/>
-            <a:ext cx="974937" cy="136080"/>
+            <a:off x="551880" y="5793795"/>
+            <a:ext cx="896313" cy="136080"/>
           </a:xfrm>
           <a:prstGeom prst="rect">
             <a:avLst/>
@@ -7022,8 +7022,8 @@
         </p:nvSpPr>
         <p:spPr>
           <a:xfrm>
-            <a:off x="551880" y="5929875"/>
-            <a:ext cx="974937" cy="151200"/>
+            <a:off x="551880" y="5975235"/>
+            <a:ext cx="896313" cy="151200"/>
           </a:xfrm>
           <a:prstGeom prst="rect">
             <a:avLst/>
@@ -7059,8 +7059,8 @@
         </p:nvSpPr>
         <p:spPr>
           <a:xfrm>
-            <a:off x="551880" y="6065955"/>
-            <a:ext cx="974937" cy="204120"/>
+            <a:off x="551880" y="6111315"/>
+            <a:ext cx="896313" cy="204120"/>
           </a:xfrm>
           <a:prstGeom prst="rect">
             <a:avLst/>
@@ -7096,8 +7096,8 @@
         </p:nvSpPr>
         <p:spPr>
           <a:xfrm>
-            <a:off x="1738800" y="5748435"/>
-            <a:ext cx="841276" cy="136080"/>
+            <a:off x="1663200" y="5793795"/>
+            <a:ext cx="762652" cy="136080"/>
           </a:xfrm>
           <a:prstGeom prst="rect">
             <a:avLst/>
@@ -7133,8 +7133,8 @@
         </p:nvSpPr>
         <p:spPr>
           <a:xfrm>
-            <a:off x="1738800" y="5929875"/>
-            <a:ext cx="841276" cy="151200"/>
+            <a:off x="1663200" y="5975235"/>
+            <a:ext cx="762652" cy="151200"/>
           </a:xfrm>
           <a:prstGeom prst="rect">
             <a:avLst/>
@@ -7170,8 +7170,8 @@
         </p:nvSpPr>
         <p:spPr>
           <a:xfrm>
-            <a:off x="1738800" y="6065955"/>
-            <a:ext cx="841276" cy="204120"/>
+            <a:off x="1663200" y="6111315"/>
+            <a:ext cx="762652" cy="204120"/>
           </a:xfrm>
           <a:prstGeom prst="rect">
             <a:avLst/>
@@ -7207,8 +7207,8 @@
         </p:nvSpPr>
         <p:spPr>
           <a:xfrm>
-            <a:off x="2797200" y="5748435"/>
-            <a:ext cx="841276" cy="136080"/>
+            <a:off x="2646000" y="5793795"/>
+            <a:ext cx="762652" cy="136080"/>
           </a:xfrm>
           <a:prstGeom prst="rect">
             <a:avLst/>
@@ -7244,8 +7244,8 @@
         </p:nvSpPr>
         <p:spPr>
           <a:xfrm>
-            <a:off x="2797200" y="5929875"/>
-            <a:ext cx="841276" cy="151200"/>
+            <a:off x="2646000" y="5975235"/>
+            <a:ext cx="762652" cy="151200"/>
           </a:xfrm>
           <a:prstGeom prst="rect">
             <a:avLst/>
@@ -7281,8 +7281,8 @@
         </p:nvSpPr>
         <p:spPr>
           <a:xfrm>
-            <a:off x="2797200" y="6065955"/>
-            <a:ext cx="841276" cy="204120"/>
+            <a:off x="2646000" y="6111315"/>
+            <a:ext cx="762652" cy="204120"/>
           </a:xfrm>
           <a:prstGeom prst="rect">
             <a:avLst/>
@@ -7318,7 +7318,7 @@
         </p:nvSpPr>
         <p:spPr>
           <a:xfrm>
-            <a:off x="2804641" y="6452932"/>
+            <a:off x="2804641" y="6498292"/>
             <a:ext cx="645085" cy="143640"/>
           </a:xfrm>
           <a:prstGeom prst="rect">
@@ -7355,7 +7355,7 @@
         </p:nvSpPr>
         <p:spPr>
           <a:xfrm>
-            <a:off x="4513556" y="6452932"/>
+            <a:off x="4513556" y="6498292"/>
             <a:ext cx="251473" cy="143640"/>
           </a:xfrm>
           <a:prstGeom prst="rect">

</xml_diff>

<commit_message>
AutomaTivio: histórico em ECharts com acumulado; comentário ajustado e centralizado; T na exportação; Central conectada
- Rentabilidade histórica em ECharts (svg) com a mesma especificação do SVG
  do servidor e o acumulado no fim de cada linha, nas duas verticais.
- Comentário do gestor: texto curto cresce até o teto e fica centralizado
  na caixa; texto longo diminui até caber.
- Mercado de Crédito: vidro em tons de azul.
- ALT: rótulo "Taxa global".
- Caixa do T: chanfro feito com borda (o html2canvas ignorava clip-path) e
  folha com canto reto — a ponta não sai mais cortada no PNG/JPG/PDF baixado.
- Central: botão de volta no e-mail Nordea e saida/AAAA-MM/index.html como
  porta de entrada.
- Saída de agosto regenerada com os comentários de agosto.

Co-Authored-By: Claude Opus 5.5 <noreply@anthropic.com>
</commit_message>
<xml_diff>
--- a/AutomaTivio/saida/2026-08/pptx/Tivio ALT 180 - Relatório de Gestão - Agosto 2026.pptx
+++ b/AutomaTivio/saida/2026-08/pptx/Tivio ALT 180 - Relatório de Gestão - Agosto 2026.pptx
@@ -5538,7 +5538,7 @@
         <p:spPr>
           <a:xfrm>
             <a:off x="415800" y="8184526"/>
-            <a:ext cx="6728400" cy="254205"/>
+            <a:ext cx="6728400" cy="253378"/>
           </a:xfrm>
           <a:prstGeom prst="rect">
             <a:avLst/>
@@ -5551,11 +5551,11 @@
           <a:p>
             <a:pPr algn="just">
               <a:lnSpc>
-                <a:spcPts val="990"/>
-              </a:lnSpc>
-            </a:pPr>
-            <a:r>
-              <a:rPr sz="839" b="0" i="0">
+                <a:spcPts val="983"/>
+              </a:lnSpc>
+            </a:pPr>
+            <a:r>
+              <a:rPr sz="833" b="0" i="0">
                 <a:solidFill>
                   <a:srgbClr val="222222"/>
                 </a:solidFill>
@@ -5574,8 +5574,8 @@
         </p:nvSpPr>
         <p:spPr>
           <a:xfrm>
-            <a:off x="415800" y="8499802"/>
-            <a:ext cx="6728400" cy="631260"/>
+            <a:off x="415800" y="8497676"/>
+            <a:ext cx="6728400" cy="627952"/>
           </a:xfrm>
           <a:prstGeom prst="rect">
             <a:avLst/>
@@ -5588,11 +5588,11 @@
           <a:p>
             <a:pPr algn="just">
               <a:lnSpc>
-                <a:spcPts val="990"/>
-              </a:lnSpc>
-            </a:pPr>
-            <a:r>
-              <a:rPr sz="839" b="0" i="0">
+                <a:spcPts val="983"/>
+              </a:lnSpc>
+            </a:pPr>
+            <a:r>
+              <a:rPr sz="833" b="0" i="0">
                 <a:solidFill>
                   <a:srgbClr val="222222"/>
                 </a:solidFill>
@@ -5611,8 +5611,8 @@
         </p:nvSpPr>
         <p:spPr>
           <a:xfrm>
-            <a:off x="415800" y="9192133"/>
-            <a:ext cx="6728400" cy="631260"/>
+            <a:off x="415800" y="9185400"/>
+            <a:ext cx="6728400" cy="627952"/>
           </a:xfrm>
           <a:prstGeom prst="rect">
             <a:avLst/>
@@ -5625,11 +5625,11 @@
           <a:p>
             <a:pPr algn="just">
               <a:lnSpc>
-                <a:spcPts val="990"/>
-              </a:lnSpc>
-            </a:pPr>
-            <a:r>
-              <a:rPr sz="839" b="0" i="0">
+                <a:spcPts val="983"/>
+              </a:lnSpc>
+            </a:pPr>
+            <a:r>
+              <a:rPr sz="833" b="0" i="0">
                 <a:solidFill>
                   <a:srgbClr val="222222"/>
                 </a:solidFill>
@@ -7791,7 +7791,7 @@
                 </a:solidFill>
                 <a:latin typeface="Versos"/>
               </a:rPr>
-              <a:t>Taxa de administração e gestão</a:t>
+              <a:t>Taxa global</a:t>
             </a:r>
           </a:p>
         </p:txBody>
@@ -8287,7 +8287,7 @@
         <p:spPr>
           <a:xfrm>
             <a:off x="400680" y="6471360"/>
-            <a:ext cx="6758640" cy="600901"/>
+            <a:ext cx="6758640" cy="593814"/>
           </a:xfrm>
           <a:prstGeom prst="rect">
             <a:avLst/>
@@ -8300,11 +8300,11 @@
           <a:p>
             <a:pPr algn="just">
               <a:lnSpc>
-                <a:spcPts val="791"/>
-              </a:lnSpc>
-            </a:pPr>
-            <a:r>
-              <a:rPr sz="648" b="0" i="0">
+                <a:spcPts val="780"/>
+              </a:lnSpc>
+            </a:pPr>
+            <a:r>
+              <a:rPr sz="639" b="0" i="0">
                 <a:solidFill>
                   <a:srgbClr val="E9E9E9"/>
                 </a:solidFill>
@@ -8323,8 +8323,8 @@
         </p:nvSpPr>
         <p:spPr>
           <a:xfrm>
-            <a:off x="400680" y="7103328"/>
-            <a:ext cx="6758640" cy="902475"/>
+            <a:off x="400680" y="7094351"/>
+            <a:ext cx="6758640" cy="891135"/>
           </a:xfrm>
           <a:prstGeom prst="rect">
             <a:avLst/>
@@ -8337,11 +8337,11 @@
           <a:p>
             <a:pPr algn="just">
               <a:lnSpc>
-                <a:spcPts val="791"/>
-              </a:lnSpc>
-            </a:pPr>
-            <a:r>
-              <a:rPr sz="648" b="0" i="0">
+                <a:spcPts val="780"/>
+              </a:lnSpc>
+            </a:pPr>
+            <a:r>
+              <a:rPr sz="639" b="0" i="0">
                 <a:solidFill>
                   <a:srgbClr val="E9E9E9"/>
                 </a:solidFill>
@@ -8360,8 +8360,8 @@
         </p:nvSpPr>
         <p:spPr>
           <a:xfrm>
-            <a:off x="400680" y="8036870"/>
-            <a:ext cx="6758640" cy="500377"/>
+            <a:off x="400680" y="8014663"/>
+            <a:ext cx="6758640" cy="494707"/>
           </a:xfrm>
           <a:prstGeom prst="rect">
             <a:avLst/>
@@ -8374,11 +8374,11 @@
           <a:p>
             <a:pPr algn="just">
               <a:lnSpc>
-                <a:spcPts val="791"/>
-              </a:lnSpc>
-            </a:pPr>
-            <a:r>
-              <a:rPr sz="648" b="0" i="0">
+                <a:spcPts val="780"/>
+              </a:lnSpc>
+            </a:pPr>
+            <a:r>
+              <a:rPr sz="639" b="0" i="0">
                 <a:solidFill>
                   <a:srgbClr val="E9E9E9"/>
                 </a:solidFill>
@@ -8397,8 +8397,8 @@
         </p:nvSpPr>
         <p:spPr>
           <a:xfrm>
-            <a:off x="400680" y="8568315"/>
-            <a:ext cx="6758640" cy="399853"/>
+            <a:off x="400680" y="8538547"/>
+            <a:ext cx="6758640" cy="395600"/>
           </a:xfrm>
           <a:prstGeom prst="rect">
             <a:avLst/>
@@ -8411,11 +8411,11 @@
           <a:p>
             <a:pPr algn="just">
               <a:lnSpc>
-                <a:spcPts val="791"/>
-              </a:lnSpc>
-            </a:pPr>
-            <a:r>
-              <a:rPr sz="648" b="0" i="0">
+                <a:spcPts val="780"/>
+              </a:lnSpc>
+            </a:pPr>
+            <a:r>
+              <a:rPr sz="639" b="0" i="0">
                 <a:solidFill>
                   <a:srgbClr val="E9E9E9"/>
                 </a:solidFill>

</xml_diff>

<commit_message>
AutomaTivio: taxas juntas à esquerda e patrimônios juntos à direita nas Características gerais
Co-Authored-By: Claude Opus 5.5 <noreply@anthropic.com>
</commit_message>
<xml_diff>
--- a/AutomaTivio/saida/2026-08/pptx/Tivio ALT 180 - Relatório de Gestão - Agosto 2026.pptx
+++ b/AutomaTivio/saida/2026-08/pptx/Tivio ALT 180 - Relatório de Gestão - Agosto 2026.pptx
@@ -7865,7 +7865,7 @@
                 </a:solidFill>
                 <a:latin typeface="Versos"/>
               </a:rPr>
-              <a:t>Patrimônio líquido</a:t>
+              <a:t>Taxa de performance</a:t>
             </a:r>
           </a:p>
         </p:txBody>
@@ -7902,7 +7902,7 @@
                 </a:solidFill>
                 <a:latin typeface="Versos"/>
               </a:rPr>
-              <a:t>R$ 151.939.343,55</a:t>
+              <a:t>20% do que exceder do CDI</a:t>
             </a:r>
           </a:p>
         </p:txBody>
@@ -7939,7 +7939,7 @@
                 </a:solidFill>
                 <a:latin typeface="Versos"/>
               </a:rPr>
-              <a:t>Taxa de performance</a:t>
+              <a:t>Informações Operacionais</a:t>
             </a:r>
           </a:p>
         </p:txBody>
@@ -7953,6 +7953,155 @@
         <p:spPr>
           <a:xfrm>
             <a:off x="3878280" y="1883857"/>
+            <a:ext cx="3281040" cy="1366351"/>
+          </a:xfrm>
+          <a:prstGeom prst="rect">
+            <a:avLst/>
+          </a:prstGeom>
+          <a:noFill/>
+        </p:spPr>
+        <p:txBody>
+          <a:bodyPr wrap="square" lIns="0" rIns="0" tIns="0" bIns="0" anchor="t"/>
+          <a:lstStyle/>
+          <a:p>
+            <a:pPr algn="l">
+              <a:lnSpc>
+                <a:spcPts val="1333"/>
+              </a:lnSpc>
+            </a:pPr>
+            <a:r>
+              <a:rPr sz="1190" b="0" i="0">
+                <a:solidFill>
+                  <a:srgbClr val="222222"/>
+                </a:solidFill>
+                <a:latin typeface="Versos"/>
+              </a:rPr>
+              <a:t>Aplicação:</a:t>
+            </a:r>
+          </a:p>
+          <a:p>
+            <a:pPr algn="l">
+              <a:lnSpc>
+                <a:spcPts val="1333"/>
+              </a:lnSpc>
+            </a:pPr>
+            <a:r>
+              <a:rPr sz="1190" b="1" i="0">
+                <a:solidFill>
+                  <a:srgbClr val="222222"/>
+                </a:solidFill>
+                <a:latin typeface="Versos"/>
+              </a:rPr>
+              <a:t>D+1</a:t>
+            </a:r>
+          </a:p>
+          <a:p>
+            <a:pPr algn="l">
+              <a:lnSpc>
+                <a:spcPts val="1333"/>
+              </a:lnSpc>
+            </a:pPr>
+            <a:r>
+              <a:rPr sz="1190" b="0" i="0">
+                <a:solidFill>
+                  <a:srgbClr val="222222"/>
+                </a:solidFill>
+                <a:latin typeface="Versos"/>
+              </a:rPr>
+              <a:t>Resgate:</a:t>
+            </a:r>
+          </a:p>
+          <a:p>
+            <a:pPr algn="l">
+              <a:lnSpc>
+                <a:spcPts val="1333"/>
+              </a:lnSpc>
+            </a:pPr>
+            <a:r>
+              <a:rPr sz="1190" b="1" i="0">
+                <a:solidFill>
+                  <a:srgbClr val="222222"/>
+                </a:solidFill>
+                <a:latin typeface="Versos"/>
+              </a:rPr>
+              <a:t>D+180</a:t>
+            </a:r>
+          </a:p>
+          <a:p>
+            <a:pPr algn="l">
+              <a:lnSpc>
+                <a:spcPts val="1333"/>
+              </a:lnSpc>
+            </a:pPr>
+            <a:r>
+              <a:rPr sz="1190" b="0" i="0">
+                <a:solidFill>
+                  <a:srgbClr val="222222"/>
+                </a:solidFill>
+                <a:latin typeface="Versos"/>
+              </a:rPr>
+              <a:t>Aplicação mínima inicial:</a:t>
+            </a:r>
+          </a:p>
+          <a:p>
+            <a:pPr algn="l">
+              <a:lnSpc>
+                <a:spcPts val="1333"/>
+              </a:lnSpc>
+            </a:pPr>
+            <a:r>
+              <a:rPr sz="1190" b="1" i="0">
+                <a:solidFill>
+                  <a:srgbClr val="222222"/>
+                </a:solidFill>
+                <a:latin typeface="Versos"/>
+              </a:rPr>
+              <a:t>R$ 1.000,00</a:t>
+            </a:r>
+          </a:p>
+          <a:p>
+            <a:pPr algn="l">
+              <a:lnSpc>
+                <a:spcPts val="1333"/>
+              </a:lnSpc>
+            </a:pPr>
+            <a:r>
+              <a:rPr sz="1190" b="0" i="0">
+                <a:solidFill>
+                  <a:srgbClr val="222222"/>
+                </a:solidFill>
+                <a:latin typeface="Versos"/>
+              </a:rPr>
+              <a:t>Movimentação mínima:</a:t>
+            </a:r>
+          </a:p>
+          <a:p>
+            <a:pPr algn="l">
+              <a:lnSpc>
+                <a:spcPts val="1333"/>
+              </a:lnSpc>
+            </a:pPr>
+            <a:r>
+              <a:rPr sz="1190" b="1" i="0">
+                <a:solidFill>
+                  <a:srgbClr val="222222"/>
+                </a:solidFill>
+                <a:latin typeface="Versos"/>
+              </a:rPr>
+              <a:t>R$ 1.000,00</a:t>
+            </a:r>
+          </a:p>
+        </p:txBody>
+      </p:sp>
+      <p:sp>
+        <p:nvSpPr>
+          <p:cNvPr id="17" name="TextBox 16"/>
+          <p:cNvSpPr txBox="1"/>
+          <p:nvPr/>
+        </p:nvSpPr>
+        <p:spPr>
+          <a:xfrm>
+            <a:off x="3878280" y="3936870"/>
             <a:ext cx="3412281" cy="181440"/>
           </a:xfrm>
           <a:prstGeom prst="rect">
@@ -7966,6 +8115,43 @@
           <a:p>
             <a:pPr algn="l">
               <a:lnSpc>
+                <a:spcPts val="1369"/>
+              </a:lnSpc>
+            </a:pPr>
+            <a:r>
+              <a:rPr sz="1190" b="1" i="0">
+                <a:solidFill>
+                  <a:srgbClr val="111111"/>
+                </a:solidFill>
+                <a:latin typeface="Versos"/>
+              </a:rPr>
+              <a:t>Patrimônio líquido</a:t>
+            </a:r>
+          </a:p>
+        </p:txBody>
+      </p:sp>
+      <p:sp>
+        <p:nvSpPr>
+          <p:cNvPr id="18" name="TextBox 17"/>
+          <p:cNvSpPr txBox="1"/>
+          <p:nvPr/>
+        </p:nvSpPr>
+        <p:spPr>
+          <a:xfrm>
+            <a:off x="3878280" y="4125870"/>
+            <a:ext cx="3412281" cy="181440"/>
+          </a:xfrm>
+          <a:prstGeom prst="rect">
+            <a:avLst/>
+          </a:prstGeom>
+          <a:noFill/>
+        </p:spPr>
+        <p:txBody>
+          <a:bodyPr wrap="none" lIns="0" rIns="0" tIns="0" bIns="0" anchor="t"/>
+          <a:lstStyle/>
+          <a:p>
+            <a:pPr algn="l">
+              <a:lnSpc>
                 <a:spcPts val="1333"/>
               </a:lnSpc>
             </a:pPr>
@@ -7976,193 +8162,7 @@
                 </a:solidFill>
                 <a:latin typeface="Versos"/>
               </a:rPr>
-              <a:t>20% do que exceder do CDI</a:t>
-            </a:r>
-          </a:p>
-        </p:txBody>
-      </p:sp>
-      <p:sp>
-        <p:nvSpPr>
-          <p:cNvPr id="17" name="TextBox 16"/>
-          <p:cNvSpPr txBox="1"/>
-          <p:nvPr/>
-        </p:nvSpPr>
-        <p:spPr>
-          <a:xfrm>
-            <a:off x="3878280" y="2385770"/>
-            <a:ext cx="3412281" cy="181440"/>
-          </a:xfrm>
-          <a:prstGeom prst="rect">
-            <a:avLst/>
-          </a:prstGeom>
-          <a:noFill/>
-        </p:spPr>
-        <p:txBody>
-          <a:bodyPr wrap="none" lIns="0" rIns="0" tIns="0" bIns="0" anchor="t"/>
-          <a:lstStyle/>
-          <a:p>
-            <a:pPr algn="l">
-              <a:lnSpc>
-                <a:spcPts val="1369"/>
-              </a:lnSpc>
-            </a:pPr>
-            <a:r>
-              <a:rPr sz="1190" b="1" i="0">
-                <a:solidFill>
-                  <a:srgbClr val="111111"/>
-                </a:solidFill>
-                <a:latin typeface="Versos"/>
-              </a:rPr>
-              <a:t>Informações Operacionais</a:t>
-            </a:r>
-          </a:p>
-        </p:txBody>
-      </p:sp>
-      <p:sp>
-        <p:nvSpPr>
-          <p:cNvPr id="18" name="TextBox 17"/>
-          <p:cNvSpPr txBox="1"/>
-          <p:nvPr/>
-        </p:nvSpPr>
-        <p:spPr>
-          <a:xfrm>
-            <a:off x="3878280" y="2574770"/>
-            <a:ext cx="3281040" cy="1366351"/>
-          </a:xfrm>
-          <a:prstGeom prst="rect">
-            <a:avLst/>
-          </a:prstGeom>
-          <a:noFill/>
-        </p:spPr>
-        <p:txBody>
-          <a:bodyPr wrap="square" lIns="0" rIns="0" tIns="0" bIns="0" anchor="t"/>
-          <a:lstStyle/>
-          <a:p>
-            <a:pPr algn="l">
-              <a:lnSpc>
-                <a:spcPts val="1333"/>
-              </a:lnSpc>
-            </a:pPr>
-            <a:r>
-              <a:rPr sz="1190" b="0" i="0">
-                <a:solidFill>
-                  <a:srgbClr val="222222"/>
-                </a:solidFill>
-                <a:latin typeface="Versos"/>
-              </a:rPr>
-              <a:t>Aplicação:</a:t>
-            </a:r>
-          </a:p>
-          <a:p>
-            <a:pPr algn="l">
-              <a:lnSpc>
-                <a:spcPts val="1333"/>
-              </a:lnSpc>
-            </a:pPr>
-            <a:r>
-              <a:rPr sz="1190" b="1" i="0">
-                <a:solidFill>
-                  <a:srgbClr val="222222"/>
-                </a:solidFill>
-                <a:latin typeface="Versos"/>
-              </a:rPr>
-              <a:t>D+1</a:t>
-            </a:r>
-          </a:p>
-          <a:p>
-            <a:pPr algn="l">
-              <a:lnSpc>
-                <a:spcPts val="1333"/>
-              </a:lnSpc>
-            </a:pPr>
-            <a:r>
-              <a:rPr sz="1190" b="0" i="0">
-                <a:solidFill>
-                  <a:srgbClr val="222222"/>
-                </a:solidFill>
-                <a:latin typeface="Versos"/>
-              </a:rPr>
-              <a:t>Resgate:</a:t>
-            </a:r>
-          </a:p>
-          <a:p>
-            <a:pPr algn="l">
-              <a:lnSpc>
-                <a:spcPts val="1333"/>
-              </a:lnSpc>
-            </a:pPr>
-            <a:r>
-              <a:rPr sz="1190" b="1" i="0">
-                <a:solidFill>
-                  <a:srgbClr val="222222"/>
-                </a:solidFill>
-                <a:latin typeface="Versos"/>
-              </a:rPr>
-              <a:t>D+180</a:t>
-            </a:r>
-          </a:p>
-          <a:p>
-            <a:pPr algn="l">
-              <a:lnSpc>
-                <a:spcPts val="1333"/>
-              </a:lnSpc>
-            </a:pPr>
-            <a:r>
-              <a:rPr sz="1190" b="0" i="0">
-                <a:solidFill>
-                  <a:srgbClr val="222222"/>
-                </a:solidFill>
-                <a:latin typeface="Versos"/>
-              </a:rPr>
-              <a:t>Aplicação mínima inicial:</a:t>
-            </a:r>
-          </a:p>
-          <a:p>
-            <a:pPr algn="l">
-              <a:lnSpc>
-                <a:spcPts val="1333"/>
-              </a:lnSpc>
-            </a:pPr>
-            <a:r>
-              <a:rPr sz="1190" b="1" i="0">
-                <a:solidFill>
-                  <a:srgbClr val="222222"/>
-                </a:solidFill>
-                <a:latin typeface="Versos"/>
-              </a:rPr>
-              <a:t>R$ 1.000,00</a:t>
-            </a:r>
-          </a:p>
-          <a:p>
-            <a:pPr algn="l">
-              <a:lnSpc>
-                <a:spcPts val="1333"/>
-              </a:lnSpc>
-            </a:pPr>
-            <a:r>
-              <a:rPr sz="1190" b="0" i="0">
-                <a:solidFill>
-                  <a:srgbClr val="222222"/>
-                </a:solidFill>
-                <a:latin typeface="Versos"/>
-              </a:rPr>
-              <a:t>Movimentação mínima:</a:t>
-            </a:r>
-          </a:p>
-          <a:p>
-            <a:pPr algn="l">
-              <a:lnSpc>
-                <a:spcPts val="1333"/>
-              </a:lnSpc>
-            </a:pPr>
-            <a:r>
-              <a:rPr sz="1190" b="1" i="0">
-                <a:solidFill>
-                  <a:srgbClr val="222222"/>
-                </a:solidFill>
-                <a:latin typeface="Versos"/>
-              </a:rPr>
-              <a:t>R$ 1.000,00</a:t>
+              <a:t>R$ 151.939.343,55</a:t>
             </a:r>
           </a:p>
         </p:txBody>

</xml_diff>

<commit_message>
AutomaTivio: selo "Rating S&P / brAMP1" nos relatórios e no one-pager, como nos posts
Co-Authored-By: Claude Opus 5.5 <noreply@anthropic.com>
</commit_message>
<xml_diff>
--- a/AutomaTivio/saida/2026-08/pptx/Tivio ALT 180 - Relatório de Gestão - Agosto 2026.pptx
+++ b/AutomaTivio/saida/2026-08/pptx/Tivio ALT 180 - Relatório de Gestão - Agosto 2026.pptx
@@ -8615,7 +8615,7 @@
         <p:spPr>
           <a:xfrm>
             <a:off x="4528440" y="10020071"/>
-            <a:ext cx="500613" cy="98280"/>
+            <a:ext cx="527886" cy="98280"/>
           </a:xfrm>
           <a:prstGeom prst="rect">
             <a:avLst/>
@@ -8638,7 +8638,7 @@
                 </a:solidFill>
                 <a:latin typeface="Versos"/>
               </a:rPr>
-              <a:t>RATING S&amp;P:</a:t>
+              <a:t>Rating S&amp;P</a:t>
             </a:r>
           </a:p>
         </p:txBody>
@@ -8652,7 +8652,7 @@
         <p:spPr>
           <a:xfrm>
             <a:off x="4528440" y="10110791"/>
-            <a:ext cx="500613" cy="166320"/>
+            <a:ext cx="527886" cy="166320"/>
           </a:xfrm>
           <a:prstGeom prst="rect">
             <a:avLst/>
@@ -8675,7 +8675,7 @@
                 </a:solidFill>
                 <a:latin typeface="Versos"/>
               </a:rPr>
-              <a:t>AMP-1</a:t>
+              <a:t>brAMP1</a:t>
             </a:r>
           </a:p>
         </p:txBody>

</xml_diff>

<commit_message>
AutomaTivio: disclaimer dos relatórios vira "MATERIAL TÉCNICO" com o texto novo
Co-Authored-By: Claude Opus 5.5 <noreply@anthropic.com>
</commit_message>
<xml_diff>
--- a/AutomaTivio/saida/2026-08/pptx/Tivio ALT 180 - Relatório de Gestão - Agosto 2026.pptx
+++ b/AutomaTivio/saida/2026-08/pptx/Tivio ALT 180 - Relatório de Gestão - Agosto 2026.pptx
@@ -8273,7 +8273,7 @@
                 </a:solidFill>
                 <a:latin typeface="Versos"/>
               </a:rPr>
-              <a:t>Disclaimer</a:t>
+              <a:t>MATERIAL TÉCNICO</a:t>
             </a:r>
           </a:p>
         </p:txBody>
@@ -8287,7 +8287,7 @@
         <p:spPr>
           <a:xfrm>
             <a:off x="400680" y="6471360"/>
-            <a:ext cx="6758640" cy="593814"/>
+            <a:ext cx="6758640" cy="291178"/>
           </a:xfrm>
           <a:prstGeom prst="rect">
             <a:avLst/>
@@ -8300,17 +8300,17 @@
           <a:p>
             <a:pPr algn="just">
               <a:lnSpc>
-                <a:spcPts val="780"/>
-              </a:lnSpc>
-            </a:pPr>
-            <a:r>
-              <a:rPr sz="639" b="0" i="0">
+                <a:spcPts val="1162"/>
+              </a:lnSpc>
+            </a:pPr>
+            <a:r>
+              <a:rPr sz="952" b="0" i="0">
                 <a:solidFill>
                   <a:srgbClr val="E9E9E9"/>
                 </a:solidFill>
                 <a:latin typeface="Versos"/>
               </a:rPr>
-              <a:t>Este material foi elaborado pela Tivio Capital Distribuidora de Títulos e Valores Mobiliários S.A. (“TIVIO CAPITAL”). Este material é destinado aos seus receptores, fornecido unicamente para fins comerciais, não constituindo compromisso, indicação ou recomendação para iniciar ou encerrar qualquer transação. Este conteúdo não deve ser reproduzido no todo ou em parte, redistribuído ou transmitido para qualquer outra pessoa sem o consentimento prévio da TIVIO CAPITAL. Este documento não é, e não deve ser interpretado como, uma oferta de venda ou solicitação de uma oferta de compra de qualquer título ou valor mobiliário. A TIVIO CAPITAL, seus acionistas e demais empresas coligadas se eximem de qualquer responsabilidade por quaisquer prejuízos, diretos ou indiretos, que venham a decorrer da utilização deste material, de seu conteúdo e da realização de operações com base neste material.</a:t>
+              <a:t>Este material foi elaborado pela Tivio Capital Distribuidora de Títulos e Valores Mobiliários S.A. e possui caráter meramente informativo. Não constitui oferta, recomendação ou aconselhamento de investimento.</a:t>
             </a:r>
           </a:p>
         </p:txBody>
@@ -8323,8 +8323,8 @@
         </p:nvSpPr>
         <p:spPr>
           <a:xfrm>
-            <a:off x="400680" y="7094351"/>
-            <a:ext cx="6758640" cy="891135"/>
+            <a:off x="400680" y="6808725"/>
+            <a:ext cx="6758640" cy="438716"/>
           </a:xfrm>
           <a:prstGeom prst="rect">
             <a:avLst/>
@@ -8337,17 +8337,17 @@
           <a:p>
             <a:pPr algn="just">
               <a:lnSpc>
-                <a:spcPts val="780"/>
-              </a:lnSpc>
-            </a:pPr>
-            <a:r>
-              <a:rPr sz="639" b="0" i="0">
+                <a:spcPts val="1162"/>
+              </a:lnSpc>
+            </a:pPr>
+            <a:r>
+              <a:rPr sz="952" b="0" i="0">
                 <a:solidFill>
                   <a:srgbClr val="E9E9E9"/>
                 </a:solidFill>
                 <a:latin typeface="Versos"/>
               </a:rPr>
-              <a:t>Consulte o documento de tributação para Fundos de Investimento para mais informações sobre a tributação aplicável, inclusive a regra aplicável em eventual desenquadramento, este documento está disponível em https://tivio.com/documentos/. A descrição acima não pode ser considerada como objetivo do fundo. Todas as informações legais podem ser observadas no regulamento do fundo, disponíveis no site https://tivio.com/fundos/. Os indicadores aqui apresentados devem ser utilizados como referência econômica e não parâmetro objetivo do fundo. Principais Fatores de Risco: (i) Crédito: risco de os emissores dos ativos financeiros e/ou das contrapartes não cumprirem suas obrigações de pagamento e/ou de liquidação das operações contratadas; (ii) Liquidez: risco de redução ou inexistência de demanda pelos ativos financeiros nos respectivos mercados em que são negociados; (iii) Mercado: Risco de oscilações decorrentes das flutuações de preços e cotações de mercado; (iv) Derivativos: pode não resultar nos efeitos desejados, devido a fatores como: descolamento entre o preço do derivativo e seu ativo objeto; alterações nas condições de negociação ou liquidação devido à interferência de órgãos reguladores ou dos mercados organizados onde são negociados; (v) Tratamento Tributário de Longo Prazo: O tratamento aplicável ao investidor depende da manutenção da carteira de ativos com prazo médio superior a 365 dias. Não há garantia de que o fundo terá o tratamento tributário de longo prazo.</a:t>
+              <a:t>Antes de investir, leia a lâmina de informações básicas, se aplicável, o regulamento, o formulário de informações complementares, seus anexos e apêndices. Esses documentos e informações sobre tributação estão disponíveis em tivio.com/fundos/ e tivio.com/documentos/.</a:t>
             </a:r>
           </a:p>
         </p:txBody>
@@ -8360,8 +8360,8 @@
         </p:nvSpPr>
         <p:spPr>
           <a:xfrm>
-            <a:off x="400680" y="8014663"/>
-            <a:ext cx="6758640" cy="494707"/>
+            <a:off x="400680" y="7293628"/>
+            <a:ext cx="6758640" cy="291178"/>
           </a:xfrm>
           <a:prstGeom prst="rect">
             <a:avLst/>
@@ -8374,17 +8374,17 @@
           <a:p>
             <a:pPr algn="just">
               <a:lnSpc>
-                <a:spcPts val="780"/>
-              </a:lnSpc>
-            </a:pPr>
-            <a:r>
-              <a:rPr sz="639" b="0" i="0">
+                <a:spcPts val="1162"/>
+              </a:lnSpc>
+            </a:pPr>
+            <a:r>
+              <a:rPr sz="952" b="0" i="0">
                 <a:solidFill>
                   <a:srgbClr val="E9E9E9"/>
                 </a:solidFill>
                 <a:latin typeface="Versos"/>
               </a:rPr>
-              <a:t>Leia a lâmina de informações essenciais, se houver, e o regulamento antes de investir. Estes documentos podem ser encontrados no site https://tivio.com/fundos/. Leia previamente as condições de cada produto antes de investir. Os investimentos apresentados podem não ser adequados aos seus objetivos, situação financeira ou necessidades individuais. A rentabilidade obtida no passado não representa garantia de resultados futuros. A rentabilidade divulgada não é líquida de impostos. “Os ativos financeiros integrantes nesta carteira podem não possuir liquidez imediata, podendo seus prazos e/ou rentabilidade variar de acordo com o vencimento ou prazo de resgate de cada ativo, caso seja negociado antecipadamente.</a:t>
+              <a:t>Os investimentos envolvem riscos. Consulte os documentos do fundo para conhecer sua estratégia, público-alvo, condições e principais fatores de risco.</a:t>
             </a:r>
           </a:p>
         </p:txBody>
@@ -8397,8 +8397,8 @@
         </p:nvSpPr>
         <p:spPr>
           <a:xfrm>
-            <a:off x="400680" y="8538547"/>
-            <a:ext cx="6758640" cy="395600"/>
+            <a:off x="400680" y="7630993"/>
+            <a:ext cx="6758640" cy="291178"/>
           </a:xfrm>
           <a:prstGeom prst="rect">
             <a:avLst/>
@@ -8411,17 +8411,17 @@
           <a:p>
             <a:pPr algn="just">
               <a:lnSpc>
-                <a:spcPts val="780"/>
-              </a:lnSpc>
-            </a:pPr>
-            <a:r>
-              <a:rPr sz="639" b="0" i="0">
+                <a:spcPts val="1162"/>
+              </a:lnSpc>
+            </a:pPr>
+            <a:r>
+              <a:rPr sz="952" b="0" i="0">
                 <a:solidFill>
                   <a:srgbClr val="E9E9E9"/>
                 </a:solidFill>
                 <a:latin typeface="Versos"/>
               </a:rPr>
-              <a:t>Para avaliação da performance de fundo(s) de investimento(s), é recomendável uma análise de, no mínimo, 12 (doze) meses. Fundos de investimento não contam com garantia do administrador, do gestor, de qualquer mecanismo de seguro ou do Fundo Garantidor de Crédito (FGC). O preenchimento do formulário API – Análise de Perfil do Investidor ou Suitability é essencial para garantir a adequação do perfil do cliente ao produto de investimento escolhido. Os indicadores aqui apresentados devem ser utilizados como referência econômica e não parâmetro objetivo do fundo. Material de Divulgação.</a:t>
+              <a:t>Rentabilidade obtida no passado não representa garantia de resultados futuros. A rentabilidade divulgada não é líquida de impostos.</a:t>
             </a:r>
           </a:p>
         </p:txBody>
@@ -8429,6 +8429,80 @@
       <p:sp>
         <p:nvSpPr>
           <p:cNvPr id="26" name="TextBox 25"/>
+          <p:cNvSpPr txBox="1"/>
+          <p:nvPr/>
+        </p:nvSpPr>
+        <p:spPr>
+          <a:xfrm>
+            <a:off x="400680" y="7968358"/>
+            <a:ext cx="6758640" cy="291178"/>
+          </a:xfrm>
+          <a:prstGeom prst="rect">
+            <a:avLst/>
+          </a:prstGeom>
+          <a:noFill/>
+        </p:spPr>
+        <p:txBody>
+          <a:bodyPr wrap="square" lIns="0" rIns="0" tIns="0" bIns="0" anchor="t"/>
+          <a:lstStyle/>
+          <a:p>
+            <a:pPr algn="just">
+              <a:lnSpc>
+                <a:spcPts val="1162"/>
+              </a:lnSpc>
+            </a:pPr>
+            <a:r>
+              <a:rPr sz="952" b="0" i="0">
+                <a:solidFill>
+                  <a:srgbClr val="E9E9E9"/>
+                </a:solidFill>
+                <a:latin typeface="Versos"/>
+              </a:rPr>
+              <a:t>Os investimentos em fundos não são garantidos pelo administrador, pelo gestor, por qualquer mecanismo de seguro ou pelo Fundo Garantidor de Crédito – FGC.</a:t>
+            </a:r>
+          </a:p>
+        </p:txBody>
+      </p:sp>
+      <p:sp>
+        <p:nvSpPr>
+          <p:cNvPr id="27" name="TextBox 26"/>
+          <p:cNvSpPr txBox="1"/>
+          <p:nvPr/>
+        </p:nvSpPr>
+        <p:spPr>
+          <a:xfrm>
+            <a:off x="400680" y="8305723"/>
+            <a:ext cx="6758640" cy="291178"/>
+          </a:xfrm>
+          <a:prstGeom prst="rect">
+            <a:avLst/>
+          </a:prstGeom>
+          <a:noFill/>
+        </p:spPr>
+        <p:txBody>
+          <a:bodyPr wrap="square" lIns="0" rIns="0" tIns="0" bIns="0" anchor="t"/>
+          <a:lstStyle/>
+          <a:p>
+            <a:pPr algn="just">
+              <a:lnSpc>
+                <a:spcPts val="1162"/>
+              </a:lnSpc>
+            </a:pPr>
+            <a:r>
+              <a:rPr sz="952" b="0" i="0">
+                <a:solidFill>
+                  <a:srgbClr val="E9E9E9"/>
+                </a:solidFill>
+                <a:latin typeface="Versos"/>
+              </a:rPr>
+              <a:t>A Tivio Capital Distribuidora de Títulos e Valores Mobiliários S.A. integra o conglomerado prudencial liderado pelo Banco Bradesco S.A.</a:t>
+            </a:r>
+          </a:p>
+        </p:txBody>
+      </p:sp>
+      <p:sp>
+        <p:nvSpPr>
+          <p:cNvPr id="28" name="TextBox 27"/>
           <p:cNvSpPr txBox="1"/>
           <p:nvPr/>
         </p:nvSpPr>
@@ -8481,7 +8555,7 @@
       </p:sp>
       <p:sp>
         <p:nvSpPr>
-          <p:cNvPr id="27" name="TextBox 26"/>
+          <p:cNvPr id="29" name="TextBox 28"/>
           <p:cNvSpPr txBox="1"/>
           <p:nvPr/>
         </p:nvSpPr>
@@ -8534,7 +8608,7 @@
       </p:sp>
       <p:sp>
         <p:nvSpPr>
-          <p:cNvPr id="28" name="TextBox 27"/>
+          <p:cNvPr id="30" name="TextBox 29"/>
           <p:cNvSpPr txBox="1"/>
           <p:nvPr/>
         </p:nvSpPr>
@@ -8571,7 +8645,7 @@
       </p:sp>
       <p:sp>
         <p:nvSpPr>
-          <p:cNvPr id="29" name="TextBox 28"/>
+          <p:cNvPr id="31" name="TextBox 30"/>
           <p:cNvSpPr txBox="1"/>
           <p:nvPr/>
         </p:nvSpPr>
@@ -8608,7 +8682,7 @@
       </p:sp>
       <p:sp>
         <p:nvSpPr>
-          <p:cNvPr id="30" name="TextBox 29"/>
+          <p:cNvPr id="32" name="TextBox 31"/>
           <p:cNvSpPr txBox="1"/>
           <p:nvPr/>
         </p:nvSpPr>
@@ -8645,7 +8719,7 @@
       </p:sp>
       <p:sp>
         <p:nvSpPr>
-          <p:cNvPr id="31" name="TextBox 30"/>
+          <p:cNvPr id="33" name="TextBox 32"/>
           <p:cNvSpPr txBox="1"/>
           <p:nvPr/>
         </p:nvSpPr>

</xml_diff>

<commit_message>
AutomaTivio: taxa do Legacy pelo CNPJ publicado; SAC e Ouvidoria no corpo do disclaimer
- Taxa e performance são buscadas pelo cnpj_exibido quando ele existe: no
  Legacy o CNPJ da DePara é outra classe, com taxa 0%; o publicado tem 0,50%.
- SAC e Ouvidoria acompanham o corpo do texto do disclaimer.

Co-Authored-By: Claude Opus 5.5 <noreply@anthropic.com>
</commit_message>
<xml_diff>
--- a/AutomaTivio/saida/2026-08/pptx/Tivio ALT 180 - Relatório de Gestão - Agosto 2026.pptx
+++ b/AutomaTivio/saida/2026-08/pptx/Tivio ALT 180 - Relatório de Gestão - Agosto 2026.pptx
@@ -8508,8 +8508,8 @@
         </p:nvSpPr>
         <p:spPr>
           <a:xfrm>
-            <a:off x="400680" y="9086056"/>
-            <a:ext cx="859477" cy="200221"/>
+            <a:off x="400680" y="8987540"/>
+            <a:ext cx="1273269" cy="294840"/>
           </a:xfrm>
           <a:prstGeom prst="rect">
             <a:avLst/>
@@ -8522,11 +8522,11 @@
           <a:p>
             <a:pPr algn="l">
               <a:lnSpc>
-                <a:spcPts val="803"/>
-              </a:lnSpc>
-            </a:pPr>
-            <a:r>
-              <a:rPr sz="642" b="0" i="0">
+                <a:spcPts val="1190"/>
+              </a:lnSpc>
+            </a:pPr>
+            <a:r>
+              <a:rPr sz="952" b="0" i="0">
                 <a:solidFill>
                   <a:srgbClr val="E9E9E9"/>
                 </a:solidFill>
@@ -8538,11 +8538,11 @@
           <a:p>
             <a:pPr algn="l">
               <a:lnSpc>
-                <a:spcPts val="803"/>
-              </a:lnSpc>
-            </a:pPr>
-            <a:r>
-              <a:rPr sz="642" b="0" i="0">
+                <a:spcPts val="1190"/>
+              </a:lnSpc>
+            </a:pPr>
+            <a:r>
+              <a:rPr sz="952" b="0" i="0">
                 <a:solidFill>
                   <a:srgbClr val="E9E9E9"/>
                 </a:solidFill>
@@ -8561,8 +8561,8 @@
         </p:nvSpPr>
         <p:spPr>
           <a:xfrm>
-            <a:off x="1381117" y="9086056"/>
-            <a:ext cx="3049987" cy="200221"/>
+            <a:off x="1794909" y="8987540"/>
+            <a:ext cx="4518399" cy="294840"/>
           </a:xfrm>
           <a:prstGeom prst="rect">
             <a:avLst/>
@@ -8575,11 +8575,11 @@
           <a:p>
             <a:pPr algn="l">
               <a:lnSpc>
-                <a:spcPts val="803"/>
-              </a:lnSpc>
-            </a:pPr>
-            <a:r>
-              <a:rPr sz="642" b="0" i="0">
+                <a:spcPts val="1190"/>
+              </a:lnSpc>
+            </a:pPr>
+            <a:r>
+              <a:rPr sz="952" b="0" i="0">
                 <a:solidFill>
                   <a:srgbClr val="E9E9E9"/>
                 </a:solidFill>
@@ -8591,11 +8591,11 @@
           <a:p>
             <a:pPr algn="l">
               <a:lnSpc>
-                <a:spcPts val="803"/>
-              </a:lnSpc>
-            </a:pPr>
-            <a:r>
-              <a:rPr sz="642" b="0" i="0">
+                <a:spcPts val="1190"/>
+              </a:lnSpc>
+            </a:pPr>
+            <a:r>
+              <a:rPr sz="952" b="0" i="0">
                 <a:solidFill>
                   <a:srgbClr val="E9E9E9"/>
                 </a:solidFill>

</xml_diff>

<commit_message>
AutomaTivio: alocação real dos ALT pelo Book Maravi com de-para (visão da gestão)
- configs/fundos.yml: tabelas book_depara `alt` (ALT 90, ALT 180, HYD60) e
  `alt_light`; os percentuais dos books de mesmo rótulo são somados.
- ContextoFundo.alocacao_real: um corte só, usado pelo treemap do
  relatório e pelo post de Crédito Estruturado. Fundo sem book_depara segue
  no corte antigo (Tipo aj. + tipo_label).

Co-Authored-By: Claude Opus 5.5 <noreply@anthropic.com>
</commit_message>
<xml_diff>
--- a/AutomaTivio/saida/2026-08/pptx/Tivio ALT 180 - Relatório de Gestão - Agosto 2026.pptx
+++ b/AutomaTivio/saida/2026-08/pptx/Tivio ALT 180 - Relatório de Gestão - Agosto 2026.pptx
@@ -4657,7 +4657,7 @@
         <p:spPr>
           <a:xfrm>
             <a:off x="498960" y="6275863"/>
-            <a:ext cx="2986790" cy="292477"/>
+            <a:ext cx="2949699" cy="292477"/>
           </a:xfrm>
           <a:prstGeom prst="rect">
             <a:avLst/>
@@ -4680,7 +4680,7 @@
                 </a:solidFill>
                 <a:latin typeface="Versos"/>
               </a:rPr>
-              <a:t>FIDCs</a:t>
+              <a:t>FIDC</a:t>
             </a:r>
           </a:p>
           <a:p>
@@ -4696,7 +4696,7 @@
                 </a:solidFill>
                 <a:latin typeface="Versos"/>
               </a:rPr>
-              <a:t>Cotas Sênior</a:t>
+              <a:t>Sênior</a:t>
             </a:r>
           </a:p>
         </p:txBody>
@@ -4710,7 +4710,7 @@
         <p:spPr>
           <a:xfrm>
             <a:off x="498960" y="6573538"/>
-            <a:ext cx="3106262" cy="189000"/>
+            <a:ext cx="3067687" cy="189000"/>
           </a:xfrm>
           <a:prstGeom prst="rect">
             <a:avLst/>
@@ -4733,7 +4733,7 @@
                 </a:solidFill>
                 <a:latin typeface="Versos"/>
               </a:rPr>
-              <a:t>46,9%</a:t>
+              <a:t>46,3%</a:t>
             </a:r>
           </a:p>
         </p:txBody>
@@ -4746,8 +4746,8 @@
         </p:nvSpPr>
         <p:spPr>
           <a:xfrm>
-            <a:off x="3682310" y="6275863"/>
-            <a:ext cx="1639929" cy="292477"/>
+            <a:off x="3645219" y="6275863"/>
+            <a:ext cx="1640047" cy="292477"/>
           </a:xfrm>
           <a:prstGeom prst="rect">
             <a:avLst/>
@@ -4770,7 +4770,7 @@
                 </a:solidFill>
                 <a:latin typeface="Versos"/>
               </a:rPr>
-              <a:t>FIDCs</a:t>
+              <a:t>FIDC</a:t>
             </a:r>
           </a:p>
           <a:p>
@@ -4786,7 +4786,7 @@
                 </a:solidFill>
                 <a:latin typeface="Versos"/>
               </a:rPr>
-              <a:t>Cotas Mezanino</a:t>
+              <a:t>Mezanino</a:t>
             </a:r>
           </a:p>
         </p:txBody>
@@ -4799,8 +4799,8 @@
         </p:nvSpPr>
         <p:spPr>
           <a:xfrm>
-            <a:off x="3682310" y="6573538"/>
-            <a:ext cx="1705526" cy="189000"/>
+            <a:off x="3645219" y="6573538"/>
+            <a:ext cx="1705649" cy="189000"/>
           </a:xfrm>
           <a:prstGeom prst="rect">
             <a:avLst/>
@@ -4836,31 +4836,31 @@
         </p:nvSpPr>
         <p:spPr>
           <a:xfrm>
-            <a:off x="5483244" y="5852503"/>
-            <a:ext cx="685380" cy="136080"/>
-          </a:xfrm>
-          <a:prstGeom prst="rect">
-            <a:avLst/>
-          </a:prstGeom>
-          <a:noFill/>
-        </p:spPr>
-        <p:txBody>
-          <a:bodyPr wrap="none" lIns="0" rIns="0" tIns="0" bIns="0" anchor="t"/>
-          <a:lstStyle/>
-          <a:p>
-            <a:pPr algn="l">
-              <a:lnSpc>
-                <a:spcPts val="949"/>
-              </a:lnSpc>
-            </a:pPr>
-            <a:r>
-              <a:rPr sz="863" b="0" i="0">
+            <a:off x="5445562" y="6468406"/>
+            <a:ext cx="673709" cy="136080"/>
+          </a:xfrm>
+          <a:prstGeom prst="rect">
+            <a:avLst/>
+          </a:prstGeom>
+          <a:noFill/>
+        </p:spPr>
+        <p:txBody>
+          <a:bodyPr wrap="none" lIns="0" rIns="0" tIns="0" bIns="0" anchor="t"/>
+          <a:lstStyle/>
+          <a:p>
+            <a:pPr algn="l">
+              <a:lnSpc>
+                <a:spcPts val="936"/>
+              </a:lnSpc>
+            </a:pPr>
+            <a:r>
+              <a:rPr sz="851" b="0" i="0">
                 <a:solidFill>
                   <a:srgbClr val="FFFFFF"/>
                 </a:solidFill>
                 <a:latin typeface="Versos"/>
               </a:rPr>
-              <a:t>Bancário</a:t>
+              <a:t>Liquidez</a:t>
             </a:r>
           </a:p>
         </p:txBody>
@@ -4873,8 +4873,8 @@
         </p:nvSpPr>
         <p:spPr>
           <a:xfrm>
-            <a:off x="5483244" y="5995670"/>
-            <a:ext cx="685380" cy="189000"/>
+            <a:off x="5445562" y="6609920"/>
+            <a:ext cx="673709" cy="189000"/>
           </a:xfrm>
           <a:prstGeom prst="rect">
             <a:avLst/>
@@ -4897,7 +4897,7 @@
                 </a:solidFill>
                 <a:latin typeface="Versos"/>
               </a:rPr>
-              <a:t>6,1%</a:t>
+              <a:t>11,4%</a:t>
             </a:r>
           </a:p>
         </p:txBody>
@@ -4910,30 +4910,210 @@
         </p:nvSpPr>
         <p:spPr>
           <a:xfrm>
-            <a:off x="5483244" y="6465808"/>
-            <a:ext cx="685380" cy="136080"/>
-          </a:xfrm>
-          <a:prstGeom prst="rect">
-            <a:avLst/>
-          </a:prstGeom>
-          <a:noFill/>
-        </p:spPr>
-        <p:txBody>
-          <a:bodyPr wrap="none" lIns="0" rIns="0" tIns="0" bIns="0" anchor="t"/>
-          <a:lstStyle/>
-          <a:p>
-            <a:pPr algn="l">
-              <a:lnSpc>
-                <a:spcPts val="949"/>
-              </a:lnSpc>
-            </a:pPr>
-            <a:r>
-              <a:rPr sz="863" b="0" i="0">
+            <a:off x="6204397" y="5929756"/>
+            <a:ext cx="518214" cy="200694"/>
+          </a:xfrm>
+          <a:prstGeom prst="rect">
+            <a:avLst/>
+          </a:prstGeom>
+          <a:noFill/>
+        </p:spPr>
+        <p:txBody>
+          <a:bodyPr wrap="square" lIns="0" rIns="0" tIns="0" bIns="0" anchor="t"/>
+          <a:lstStyle/>
+          <a:p>
+            <a:pPr algn="l">
+              <a:lnSpc>
+                <a:spcPts val="746"/>
+              </a:lnSpc>
+            </a:pPr>
+            <a:r>
+              <a:rPr sz="678" b="0" i="0">
                 <a:solidFill>
                   <a:srgbClr val="2B3744"/>
                 </a:solidFill>
                 <a:latin typeface="Versos"/>
               </a:rPr>
+              <a:t>Crédito</a:t>
+            </a:r>
+          </a:p>
+          <a:p>
+            <a:pPr algn="l">
+              <a:lnSpc>
+                <a:spcPts val="746"/>
+              </a:lnSpc>
+            </a:pPr>
+            <a:r>
+              <a:rPr sz="678" b="1" i="0">
+                <a:solidFill>
+                  <a:srgbClr val="2B3744"/>
+                </a:solidFill>
+                <a:latin typeface="Versos"/>
+              </a:rPr>
+              <a:t>Estruturado</a:t>
+            </a:r>
+          </a:p>
+        </p:txBody>
+      </p:sp>
+      <p:sp>
+        <p:nvSpPr>
+          <p:cNvPr id="50" name="TextBox 49"/>
+          <p:cNvSpPr txBox="1"/>
+          <p:nvPr/>
+        </p:nvSpPr>
+        <p:spPr>
+          <a:xfrm>
+            <a:off x="6204397" y="6134585"/>
+            <a:ext cx="538942" cy="158760"/>
+          </a:xfrm>
+          <a:prstGeom prst="rect">
+            <a:avLst/>
+          </a:prstGeom>
+          <a:noFill/>
+        </p:spPr>
+        <p:txBody>
+          <a:bodyPr wrap="none" lIns="0" rIns="0" tIns="0" bIns="0" anchor="t"/>
+          <a:lstStyle/>
+          <a:p>
+            <a:pPr algn="l">
+              <a:lnSpc>
+                <a:spcPts val="1145"/>
+              </a:lnSpc>
+            </a:pPr>
+            <a:r>
+              <a:rPr sz="1041" b="1" i="0">
+                <a:solidFill>
+                  <a:srgbClr val="2B3744"/>
+                </a:solidFill>
+                <a:latin typeface="Versos"/>
+              </a:rPr>
+              <a:t>5,5%</a:t>
+            </a:r>
+          </a:p>
+        </p:txBody>
+      </p:sp>
+      <p:sp>
+        <p:nvSpPr>
+          <p:cNvPr id="51" name="TextBox 50"/>
+          <p:cNvSpPr txBox="1"/>
+          <p:nvPr/>
+        </p:nvSpPr>
+        <p:spPr>
+          <a:xfrm>
+            <a:off x="6809670" y="6051898"/>
+            <a:ext cx="311731" cy="142104"/>
+          </a:xfrm>
+          <a:prstGeom prst="rect">
+            <a:avLst/>
+          </a:prstGeom>
+          <a:noFill/>
+        </p:spPr>
+        <p:txBody>
+          <a:bodyPr wrap="square" lIns="0" rIns="0" tIns="0" bIns="0" anchor="t"/>
+          <a:lstStyle/>
+          <a:p>
+            <a:pPr algn="l">
+              <a:lnSpc>
+                <a:spcPts val="523"/>
+              </a:lnSpc>
+            </a:pPr>
+            <a:r>
+              <a:rPr sz="476" b="0" i="0">
+                <a:solidFill>
+                  <a:srgbClr val="2B3744"/>
+                </a:solidFill>
+                <a:latin typeface="Versos"/>
+              </a:rPr>
+              <a:t>Crédito</a:t>
+            </a:r>
+          </a:p>
+          <a:p>
+            <a:pPr algn="l">
+              <a:lnSpc>
+                <a:spcPts val="523"/>
+              </a:lnSpc>
+            </a:pPr>
+            <a:r>
+              <a:rPr sz="476" b="1" i="0">
+                <a:solidFill>
+                  <a:srgbClr val="2B3744"/>
+                </a:solidFill>
+                <a:latin typeface="Versos"/>
+              </a:rPr>
+              <a:t>Privado</a:t>
+            </a:r>
+          </a:p>
+        </p:txBody>
+      </p:sp>
+      <p:sp>
+        <p:nvSpPr>
+          <p:cNvPr id="52" name="TextBox 51"/>
+          <p:cNvSpPr txBox="1"/>
+          <p:nvPr/>
+        </p:nvSpPr>
+        <p:spPr>
+          <a:xfrm>
+            <a:off x="6809670" y="6200026"/>
+            <a:ext cx="324201" cy="98280"/>
+          </a:xfrm>
+          <a:prstGeom prst="rect">
+            <a:avLst/>
+          </a:prstGeom>
+          <a:noFill/>
+        </p:spPr>
+        <p:txBody>
+          <a:bodyPr wrap="none" lIns="0" rIns="0" tIns="0" bIns="0" anchor="t"/>
+          <a:lstStyle/>
+          <a:p>
+            <a:pPr algn="l">
+              <a:lnSpc>
+                <a:spcPts val="720"/>
+              </a:lnSpc>
+            </a:pPr>
+            <a:r>
+              <a:rPr sz="654" b="1" i="0">
+                <a:solidFill>
+                  <a:srgbClr val="2B3744"/>
+                </a:solidFill>
+                <a:latin typeface="Versos"/>
+              </a:rPr>
+              <a:t>3,4%</a:t>
+            </a:r>
+          </a:p>
+        </p:txBody>
+      </p:sp>
+      <p:sp>
+        <p:nvSpPr>
+          <p:cNvPr id="53" name="TextBox 52"/>
+          <p:cNvSpPr txBox="1"/>
+          <p:nvPr/>
+        </p:nvSpPr>
+        <p:spPr>
+          <a:xfrm>
+            <a:off x="6198255" y="6577908"/>
+            <a:ext cx="470638" cy="98280"/>
+          </a:xfrm>
+          <a:prstGeom prst="rect">
+            <a:avLst/>
+          </a:prstGeom>
+          <a:noFill/>
+        </p:spPr>
+        <p:txBody>
+          <a:bodyPr wrap="none" lIns="0" rIns="0" tIns="0" bIns="0" anchor="t"/>
+          <a:lstStyle/>
+          <a:p>
+            <a:pPr algn="l">
+              <a:lnSpc>
+                <a:spcPts val="654"/>
+              </a:lnSpc>
+            </a:pPr>
+            <a:r>
+              <a:rPr sz="595" b="0" i="0">
+                <a:solidFill>
+                  <a:srgbClr val="2B3744"/>
+                </a:solidFill>
+                <a:latin typeface="Versos"/>
+              </a:rPr>
               <a:t>Fiagro</a:t>
             </a:r>
           </a:p>
@@ -4941,36 +5121,294 @@
       </p:sp>
       <p:sp>
         <p:nvSpPr>
-          <p:cNvPr id="50" name="TextBox 49"/>
-          <p:cNvSpPr txBox="1"/>
-          <p:nvPr/>
-        </p:nvSpPr>
-        <p:spPr>
-          <a:xfrm>
-            <a:off x="5483244" y="6608975"/>
-            <a:ext cx="685380" cy="189000"/>
-          </a:xfrm>
-          <a:prstGeom prst="rect">
-            <a:avLst/>
-          </a:prstGeom>
-          <a:noFill/>
-        </p:spPr>
-        <p:txBody>
-          <a:bodyPr wrap="none" lIns="0" rIns="0" tIns="0" bIns="0" anchor="t"/>
-          <a:lstStyle/>
-          <a:p>
-            <a:pPr algn="l">
-              <a:lnSpc>
-                <a:spcPts val="1375"/>
-              </a:lnSpc>
-            </a:pPr>
-            <a:r>
-              <a:rPr sz="1250" b="1" i="0">
+          <p:cNvPr id="54" name="TextBox 53"/>
+          <p:cNvSpPr txBox="1"/>
+          <p:nvPr/>
+        </p:nvSpPr>
+        <p:spPr>
+          <a:xfrm>
+            <a:off x="6198255" y="6668628"/>
+            <a:ext cx="470638" cy="143640"/>
+          </a:xfrm>
+          <a:prstGeom prst="rect">
+            <a:avLst/>
+          </a:prstGeom>
+          <a:noFill/>
+        </p:spPr>
+        <p:txBody>
+          <a:bodyPr wrap="none" lIns="0" rIns="0" tIns="0" bIns="0" anchor="t"/>
+          <a:lstStyle/>
+          <a:p>
+            <a:pPr algn="l">
+              <a:lnSpc>
+                <a:spcPts val="1001"/>
+              </a:lnSpc>
+            </a:pPr>
+            <a:r>
+              <a:rPr sz="910" b="1" i="0">
                 <a:solidFill>
                   <a:srgbClr val="2B3744"/>
                 </a:solidFill>
                 <a:latin typeface="Versos"/>
               </a:rPr>
+              <a:t>3,2%</a:t>
+            </a:r>
+          </a:p>
+        </p:txBody>
+      </p:sp>
+      <p:sp>
+        <p:nvSpPr>
+          <p:cNvPr id="55" name="TextBox 54"/>
+          <p:cNvSpPr txBox="1"/>
+          <p:nvPr/>
+        </p:nvSpPr>
+        <p:spPr>
+          <a:xfrm>
+            <a:off x="6731707" y="6612165"/>
+            <a:ext cx="405282" cy="75600"/>
+          </a:xfrm>
+          <a:prstGeom prst="rect">
+            <a:avLst/>
+          </a:prstGeom>
+          <a:noFill/>
+        </p:spPr>
+        <p:txBody>
+          <a:bodyPr wrap="none" lIns="0" rIns="0" tIns="0" bIns="0" anchor="t"/>
+          <a:lstStyle/>
+          <a:p>
+            <a:pPr algn="l">
+              <a:lnSpc>
+                <a:spcPts val="563"/>
+              </a:lnSpc>
+            </a:pPr>
+            <a:r>
+              <a:rPr sz="511" b="0" i="0">
+                <a:solidFill>
+                  <a:srgbClr val="FFFFFF"/>
+                </a:solidFill>
+                <a:latin typeface="Versos"/>
+              </a:rPr>
+              <a:t>Precatórios</a:t>
+            </a:r>
+          </a:p>
+        </p:txBody>
+      </p:sp>
+      <p:sp>
+        <p:nvSpPr>
+          <p:cNvPr id="56" name="TextBox 55"/>
+          <p:cNvSpPr txBox="1"/>
+          <p:nvPr/>
+        </p:nvSpPr>
+        <p:spPr>
+          <a:xfrm>
+            <a:off x="6731707" y="6698750"/>
+            <a:ext cx="405282" cy="120960"/>
+          </a:xfrm>
+          <a:prstGeom prst="rect">
+            <a:avLst/>
+          </a:prstGeom>
+          <a:noFill/>
+        </p:spPr>
+        <p:txBody>
+          <a:bodyPr wrap="none" lIns="0" rIns="0" tIns="0" bIns="0" anchor="t"/>
+          <a:lstStyle/>
+          <a:p>
+            <a:pPr algn="l">
+              <a:lnSpc>
+                <a:spcPts val="864"/>
+              </a:lnSpc>
+            </a:pPr>
+            <a:r>
+              <a:rPr sz="785" b="1" i="0">
+                <a:solidFill>
+                  <a:srgbClr val="FFFFFF"/>
+                </a:solidFill>
+                <a:latin typeface="Versos"/>
+              </a:rPr>
+              <a:t>2,7%</a:t>
+            </a:r>
+          </a:p>
+        </p:txBody>
+      </p:sp>
+      <p:sp>
+        <p:nvSpPr>
+          <p:cNvPr id="57" name="TextBox 56"/>
+          <p:cNvSpPr txBox="1"/>
+          <p:nvPr/>
+        </p:nvSpPr>
+        <p:spPr>
+          <a:xfrm>
+            <a:off x="529200" y="6929566"/>
+            <a:ext cx="938082" cy="113400"/>
+          </a:xfrm>
+          <a:prstGeom prst="rect">
+            <a:avLst/>
+          </a:prstGeom>
+          <a:noFill/>
+        </p:spPr>
+        <p:txBody>
+          <a:bodyPr wrap="none" lIns="0" rIns="0" tIns="0" bIns="0" anchor="t"/>
+          <a:lstStyle/>
+          <a:p>
+            <a:pPr algn="l">
+              <a:lnSpc>
+                <a:spcPts val="892"/>
+              </a:lnSpc>
+            </a:pPr>
+            <a:r>
+              <a:rPr sz="744" b="0" i="0">
+                <a:solidFill>
+                  <a:srgbClr val="333333"/>
+                </a:solidFill>
+                <a:latin typeface="Versos"/>
+              </a:rPr>
+              <a:t>FIDC Sênior </a:t>
+            </a:r>
+            <a:r>
+              <a:rPr sz="744" b="1" i="0">
+                <a:solidFill>
+                  <a:srgbClr val="111111"/>
+                </a:solidFill>
+                <a:latin typeface="Versos"/>
+              </a:rPr>
+              <a:t>46,3%</a:t>
+            </a:r>
+          </a:p>
+        </p:txBody>
+      </p:sp>
+      <p:sp>
+        <p:nvSpPr>
+          <p:cNvPr id="58" name="TextBox 57"/>
+          <p:cNvSpPr txBox="1"/>
+          <p:nvPr/>
+        </p:nvSpPr>
+        <p:spPr>
+          <a:xfrm>
+            <a:off x="1695802" y="6929566"/>
+            <a:ext cx="1070392" cy="113400"/>
+          </a:xfrm>
+          <a:prstGeom prst="rect">
+            <a:avLst/>
+          </a:prstGeom>
+          <a:noFill/>
+        </p:spPr>
+        <p:txBody>
+          <a:bodyPr wrap="none" lIns="0" rIns="0" tIns="0" bIns="0" anchor="t"/>
+          <a:lstStyle/>
+          <a:p>
+            <a:pPr algn="l">
+              <a:lnSpc>
+                <a:spcPts val="892"/>
+              </a:lnSpc>
+            </a:pPr>
+            <a:r>
+              <a:rPr sz="744" b="0" i="0">
+                <a:solidFill>
+                  <a:srgbClr val="333333"/>
+                </a:solidFill>
+                <a:latin typeface="Versos"/>
+              </a:rPr>
+              <a:t>FIDC Mezanino </a:t>
+            </a:r>
+            <a:r>
+              <a:rPr sz="744" b="1" i="0">
+                <a:solidFill>
+                  <a:srgbClr val="111111"/>
+                </a:solidFill>
+                <a:latin typeface="Versos"/>
+              </a:rPr>
+              <a:t>27,0%</a:t>
+            </a:r>
+          </a:p>
+        </p:txBody>
+      </p:sp>
+      <p:sp>
+        <p:nvSpPr>
+          <p:cNvPr id="59" name="TextBox 58"/>
+          <p:cNvSpPr txBox="1"/>
+          <p:nvPr/>
+        </p:nvSpPr>
+        <p:spPr>
+          <a:xfrm>
+            <a:off x="2989625" y="6929566"/>
+            <a:ext cx="701350" cy="113400"/>
+          </a:xfrm>
+          <a:prstGeom prst="rect">
+            <a:avLst/>
+          </a:prstGeom>
+          <a:noFill/>
+        </p:spPr>
+        <p:txBody>
+          <a:bodyPr wrap="none" lIns="0" rIns="0" tIns="0" bIns="0" anchor="t"/>
+          <a:lstStyle/>
+          <a:p>
+            <a:pPr algn="l">
+              <a:lnSpc>
+                <a:spcPts val="892"/>
+              </a:lnSpc>
+            </a:pPr>
+            <a:r>
+              <a:rPr sz="744" b="0" i="0">
+                <a:solidFill>
+                  <a:srgbClr val="333333"/>
+                </a:solidFill>
+                <a:latin typeface="Versos"/>
+              </a:rPr>
+              <a:t>Liquidez </a:t>
+            </a:r>
+            <a:r>
+              <a:rPr sz="744" b="1" i="0">
+                <a:solidFill>
+                  <a:srgbClr val="111111"/>
+                </a:solidFill>
+                <a:latin typeface="Versos"/>
+              </a:rPr>
+              <a:t>11,4%</a:t>
+            </a:r>
+          </a:p>
+        </p:txBody>
+      </p:sp>
+      <p:sp>
+        <p:nvSpPr>
+          <p:cNvPr id="60" name="TextBox 59"/>
+          <p:cNvSpPr txBox="1"/>
+          <p:nvPr/>
+        </p:nvSpPr>
+        <p:spPr>
+          <a:xfrm>
+            <a:off x="3928601" y="6929566"/>
+            <a:ext cx="1217689" cy="113400"/>
+          </a:xfrm>
+          <a:prstGeom prst="rect">
+            <a:avLst/>
+          </a:prstGeom>
+          <a:noFill/>
+        </p:spPr>
+        <p:txBody>
+          <a:bodyPr wrap="none" lIns="0" rIns="0" tIns="0" bIns="0" anchor="t"/>
+          <a:lstStyle/>
+          <a:p>
+            <a:pPr algn="l">
+              <a:lnSpc>
+                <a:spcPts val="892"/>
+              </a:lnSpc>
+            </a:pPr>
+            <a:r>
+              <a:rPr sz="744" b="0" i="0">
+                <a:solidFill>
+                  <a:srgbClr val="333333"/>
+                </a:solidFill>
+                <a:latin typeface="Versos"/>
+              </a:rPr>
+              <a:t>Crédito Estruturado </a:t>
+            </a:r>
+            <a:r>
+              <a:rPr sz="744" b="1" i="0">
+                <a:solidFill>
+                  <a:srgbClr val="111111"/>
+                </a:solidFill>
+                <a:latin typeface="Versos"/>
+              </a:rPr>
               <a:t>5,5%</a:t>
             </a:r>
           </a:p>
@@ -4978,70 +5416,42 @@
       </p:sp>
       <p:sp>
         <p:nvSpPr>
-          <p:cNvPr id="51" name="TextBox 50"/>
-          <p:cNvSpPr txBox="1"/>
-          <p:nvPr/>
-        </p:nvSpPr>
-        <p:spPr>
-          <a:xfrm>
-            <a:off x="6281296" y="5784581"/>
-            <a:ext cx="833660" cy="189000"/>
-          </a:xfrm>
-          <a:prstGeom prst="rect">
-            <a:avLst/>
-          </a:prstGeom>
-          <a:noFill/>
-        </p:spPr>
-        <p:txBody>
-          <a:bodyPr wrap="none" lIns="0" rIns="0" tIns="0" bIns="0" anchor="t"/>
-          <a:lstStyle/>
-          <a:p>
-            <a:pPr algn="l">
-              <a:lnSpc>
-                <a:spcPts val="1375"/>
-              </a:lnSpc>
-            </a:pPr>
-            <a:r>
-              <a:rPr sz="1250" b="1" i="0">
-                <a:solidFill>
-                  <a:srgbClr val="2B3744"/>
-                </a:solidFill>
-                <a:latin typeface="Versos"/>
-              </a:rPr>
-              <a:t>5,3%</a:t>
-            </a:r>
-          </a:p>
-        </p:txBody>
-      </p:sp>
-      <p:sp>
-        <p:nvSpPr>
-          <p:cNvPr id="52" name="TextBox 51"/>
-          <p:cNvSpPr txBox="1"/>
-          <p:nvPr/>
-        </p:nvSpPr>
-        <p:spPr>
-          <a:xfrm>
-            <a:off x="6258616" y="6267830"/>
-            <a:ext cx="584643" cy="173880"/>
-          </a:xfrm>
-          <a:prstGeom prst="rect">
-            <a:avLst/>
-          </a:prstGeom>
-          <a:noFill/>
-        </p:spPr>
-        <p:txBody>
-          <a:bodyPr wrap="none" lIns="0" rIns="0" tIns="0" bIns="0" anchor="t"/>
-          <a:lstStyle/>
-          <a:p>
-            <a:pPr algn="l">
-              <a:lnSpc>
-                <a:spcPts val="1244"/>
-              </a:lnSpc>
-            </a:pPr>
-            <a:r>
-              <a:rPr sz="1131" b="1" i="0">
-                <a:solidFill>
-                  <a:srgbClr val="2B3744"/>
+          <p:cNvPr id="61" name="TextBox 60"/>
+          <p:cNvSpPr txBox="1"/>
+          <p:nvPr/>
+        </p:nvSpPr>
+        <p:spPr>
+          <a:xfrm>
+            <a:off x="5364056" y="6929566"/>
+            <a:ext cx="1019532" cy="113400"/>
+          </a:xfrm>
+          <a:prstGeom prst="rect">
+            <a:avLst/>
+          </a:prstGeom>
+          <a:noFill/>
+        </p:spPr>
+        <p:txBody>
+          <a:bodyPr wrap="none" lIns="0" rIns="0" tIns="0" bIns="0" anchor="t"/>
+          <a:lstStyle/>
+          <a:p>
+            <a:pPr algn="l">
+              <a:lnSpc>
+                <a:spcPts val="892"/>
+              </a:lnSpc>
+            </a:pPr>
+            <a:r>
+              <a:rPr sz="744" b="0" i="0">
+                <a:solidFill>
+                  <a:srgbClr val="333333"/>
+                </a:solidFill>
+                <a:latin typeface="Versos"/>
+              </a:rPr>
+              <a:t>Crédito Privado </a:t>
+            </a:r>
+            <a:r>
+              <a:rPr sz="744" b="1" i="0">
+                <a:solidFill>
+                  <a:srgbClr val="111111"/>
                 </a:solidFill>
                 <a:latin typeface="Versos"/>
               </a:rPr>
@@ -5052,33 +5462,88 @@
       </p:sp>
       <p:sp>
         <p:nvSpPr>
-          <p:cNvPr id="53" name="TextBox 52"/>
-          <p:cNvSpPr txBox="1"/>
-          <p:nvPr/>
-        </p:nvSpPr>
-        <p:spPr>
-          <a:xfrm>
-            <a:off x="6258616" y="6654690"/>
-            <a:ext cx="584643" cy="151200"/>
-          </a:xfrm>
-          <a:prstGeom prst="rect">
-            <a:avLst/>
-          </a:prstGeom>
-          <a:noFill/>
-        </p:spPr>
-        <p:txBody>
-          <a:bodyPr wrap="none" lIns="0" rIns="0" tIns="0" bIns="0" anchor="t"/>
-          <a:lstStyle/>
-          <a:p>
-            <a:pPr algn="l">
-              <a:lnSpc>
-                <a:spcPts val="1087"/>
-              </a:lnSpc>
-            </a:pPr>
-            <a:r>
-              <a:rPr sz="988" b="1" i="0">
-                <a:solidFill>
-                  <a:srgbClr val="FFFFFF"/>
+          <p:cNvPr id="62" name="TextBox 61"/>
+          <p:cNvSpPr txBox="1"/>
+          <p:nvPr/>
+        </p:nvSpPr>
+        <p:spPr>
+          <a:xfrm>
+            <a:off x="529200" y="7088326"/>
+            <a:ext cx="585503" cy="113400"/>
+          </a:xfrm>
+          <a:prstGeom prst="rect">
+            <a:avLst/>
+          </a:prstGeom>
+          <a:noFill/>
+        </p:spPr>
+        <p:txBody>
+          <a:bodyPr wrap="none" lIns="0" rIns="0" tIns="0" bIns="0" anchor="t"/>
+          <a:lstStyle/>
+          <a:p>
+            <a:pPr algn="l">
+              <a:lnSpc>
+                <a:spcPts val="892"/>
+              </a:lnSpc>
+            </a:pPr>
+            <a:r>
+              <a:rPr sz="744" b="0" i="0">
+                <a:solidFill>
+                  <a:srgbClr val="333333"/>
+                </a:solidFill>
+                <a:latin typeface="Versos"/>
+              </a:rPr>
+              <a:t>Fiagro </a:t>
+            </a:r>
+            <a:r>
+              <a:rPr sz="744" b="1" i="0">
+                <a:solidFill>
+                  <a:srgbClr val="111111"/>
+                </a:solidFill>
+                <a:latin typeface="Versos"/>
+              </a:rPr>
+              <a:t>3,2%</a:t>
+            </a:r>
+          </a:p>
+        </p:txBody>
+      </p:sp>
+      <p:sp>
+        <p:nvSpPr>
+          <p:cNvPr id="63" name="TextBox 62"/>
+          <p:cNvSpPr txBox="1"/>
+          <p:nvPr/>
+        </p:nvSpPr>
+        <p:spPr>
+          <a:xfrm>
+            <a:off x="1356783" y="7088326"/>
+            <a:ext cx="827640" cy="113400"/>
+          </a:xfrm>
+          <a:prstGeom prst="rect">
+            <a:avLst/>
+          </a:prstGeom>
+          <a:noFill/>
+        </p:spPr>
+        <p:txBody>
+          <a:bodyPr wrap="none" lIns="0" rIns="0" tIns="0" bIns="0" anchor="t"/>
+          <a:lstStyle/>
+          <a:p>
+            <a:pPr algn="l">
+              <a:lnSpc>
+                <a:spcPts val="892"/>
+              </a:lnSpc>
+            </a:pPr>
+            <a:r>
+              <a:rPr sz="744" b="0" i="0">
+                <a:solidFill>
+                  <a:srgbClr val="333333"/>
+                </a:solidFill>
+                <a:latin typeface="Versos"/>
+              </a:rPr>
+              <a:t>Precatórios </a:t>
+            </a:r>
+            <a:r>
+              <a:rPr sz="744" b="1" i="0">
+                <a:solidFill>
+                  <a:srgbClr val="111111"/>
                 </a:solidFill>
                 <a:latin typeface="Versos"/>
               </a:rPr>
@@ -5089,412 +5554,7 @@
       </p:sp>
       <p:sp>
         <p:nvSpPr>
-          <p:cNvPr id="54" name="TextBox 53"/>
-          <p:cNvSpPr txBox="1"/>
-          <p:nvPr/>
-        </p:nvSpPr>
-        <p:spPr>
-          <a:xfrm>
-            <a:off x="6912320" y="6729581"/>
-            <a:ext cx="217444" cy="83160"/>
-          </a:xfrm>
-          <a:prstGeom prst="rect">
-            <a:avLst/>
-          </a:prstGeom>
-          <a:noFill/>
-        </p:spPr>
-        <p:txBody>
-          <a:bodyPr wrap="none" lIns="0" rIns="0" tIns="0" bIns="0" anchor="t"/>
-          <a:lstStyle/>
-          <a:p>
-            <a:pPr algn="l">
-              <a:lnSpc>
-                <a:spcPts val="622"/>
-              </a:lnSpc>
-            </a:pPr>
-            <a:r>
-              <a:rPr sz="565" b="1" i="0">
-                <a:solidFill>
-                  <a:srgbClr val="2B3744"/>
-                </a:solidFill>
-                <a:latin typeface="Versos"/>
-              </a:rPr>
-              <a:t>2,6%</a:t>
-            </a:r>
-          </a:p>
-        </p:txBody>
-      </p:sp>
-      <p:sp>
-        <p:nvSpPr>
-          <p:cNvPr id="55" name="TextBox 54"/>
-          <p:cNvSpPr txBox="1"/>
-          <p:nvPr/>
-        </p:nvSpPr>
-        <p:spPr>
-          <a:xfrm>
-            <a:off x="529200" y="6929566"/>
-            <a:ext cx="1286730" cy="113400"/>
-          </a:xfrm>
-          <a:prstGeom prst="rect">
-            <a:avLst/>
-          </a:prstGeom>
-          <a:noFill/>
-        </p:spPr>
-        <p:txBody>
-          <a:bodyPr wrap="none" lIns="0" rIns="0" tIns="0" bIns="0" anchor="t"/>
-          <a:lstStyle/>
-          <a:p>
-            <a:pPr algn="l">
-              <a:lnSpc>
-                <a:spcPts val="892"/>
-              </a:lnSpc>
-            </a:pPr>
-            <a:r>
-              <a:rPr sz="744" b="0" i="0">
-                <a:solidFill>
-                  <a:srgbClr val="333333"/>
-                </a:solidFill>
-                <a:latin typeface="Versos"/>
-              </a:rPr>
-              <a:t>FIDCs Cotas Sênior </a:t>
-            </a:r>
-            <a:r>
-              <a:rPr sz="744" b="1" i="0">
-                <a:solidFill>
-                  <a:srgbClr val="111111"/>
-                </a:solidFill>
-                <a:latin typeface="Versos"/>
-              </a:rPr>
-              <a:t>46,9%</a:t>
-            </a:r>
-          </a:p>
-        </p:txBody>
-      </p:sp>
-      <p:sp>
-        <p:nvSpPr>
-          <p:cNvPr id="56" name="TextBox 55"/>
-          <p:cNvSpPr txBox="1"/>
-          <p:nvPr/>
-        </p:nvSpPr>
-        <p:spPr>
-          <a:xfrm>
-            <a:off x="2031041" y="6929566"/>
-            <a:ext cx="1419408" cy="113400"/>
-          </a:xfrm>
-          <a:prstGeom prst="rect">
-            <a:avLst/>
-          </a:prstGeom>
-          <a:noFill/>
-        </p:spPr>
-        <p:txBody>
-          <a:bodyPr wrap="none" lIns="0" rIns="0" tIns="0" bIns="0" anchor="t"/>
-          <a:lstStyle/>
-          <a:p>
-            <a:pPr algn="l">
-              <a:lnSpc>
-                <a:spcPts val="892"/>
-              </a:lnSpc>
-            </a:pPr>
-            <a:r>
-              <a:rPr sz="744" b="0" i="0">
-                <a:solidFill>
-                  <a:srgbClr val="333333"/>
-                </a:solidFill>
-                <a:latin typeface="Versos"/>
-              </a:rPr>
-              <a:t>FIDCs Cotas Mezanino </a:t>
-            </a:r>
-            <a:r>
-              <a:rPr sz="744" b="1" i="0">
-                <a:solidFill>
-                  <a:srgbClr val="111111"/>
-                </a:solidFill>
-                <a:latin typeface="Versos"/>
-              </a:rPr>
-              <a:t>27,0%</a:t>
-            </a:r>
-          </a:p>
-        </p:txBody>
-      </p:sp>
-      <p:sp>
-        <p:nvSpPr>
-          <p:cNvPr id="57" name="TextBox 56"/>
-          <p:cNvSpPr txBox="1"/>
-          <p:nvPr/>
-        </p:nvSpPr>
-        <p:spPr>
-          <a:xfrm>
-            <a:off x="3660457" y="6929566"/>
-            <a:ext cx="681817" cy="113400"/>
-          </a:xfrm>
-          <a:prstGeom prst="rect">
-            <a:avLst/>
-          </a:prstGeom>
-          <a:noFill/>
-        </p:spPr>
-        <p:txBody>
-          <a:bodyPr wrap="none" lIns="0" rIns="0" tIns="0" bIns="0" anchor="t"/>
-          <a:lstStyle/>
-          <a:p>
-            <a:pPr algn="l">
-              <a:lnSpc>
-                <a:spcPts val="892"/>
-              </a:lnSpc>
-            </a:pPr>
-            <a:r>
-              <a:rPr sz="744" b="0" i="0">
-                <a:solidFill>
-                  <a:srgbClr val="333333"/>
-                </a:solidFill>
-                <a:latin typeface="Versos"/>
-              </a:rPr>
-              <a:t>Bancário </a:t>
-            </a:r>
-            <a:r>
-              <a:rPr sz="744" b="1" i="0">
-                <a:solidFill>
-                  <a:srgbClr val="111111"/>
-                </a:solidFill>
-                <a:latin typeface="Versos"/>
-              </a:rPr>
-              <a:t>6,1%</a:t>
-            </a:r>
-          </a:p>
-        </p:txBody>
-      </p:sp>
-      <p:sp>
-        <p:nvSpPr>
-          <p:cNvPr id="58" name="TextBox 57"/>
-          <p:cNvSpPr txBox="1"/>
-          <p:nvPr/>
-        </p:nvSpPr>
-        <p:spPr>
-          <a:xfrm>
-            <a:off x="4580651" y="6929566"/>
-            <a:ext cx="582800" cy="113400"/>
-          </a:xfrm>
-          <a:prstGeom prst="rect">
-            <a:avLst/>
-          </a:prstGeom>
-          <a:noFill/>
-        </p:spPr>
-        <p:txBody>
-          <a:bodyPr wrap="none" lIns="0" rIns="0" tIns="0" bIns="0" anchor="t"/>
-          <a:lstStyle/>
-          <a:p>
-            <a:pPr algn="l">
-              <a:lnSpc>
-                <a:spcPts val="892"/>
-              </a:lnSpc>
-            </a:pPr>
-            <a:r>
-              <a:rPr sz="744" b="0" i="0">
-                <a:solidFill>
-                  <a:srgbClr val="333333"/>
-                </a:solidFill>
-                <a:latin typeface="Versos"/>
-              </a:rPr>
-              <a:t>Fiagro </a:t>
-            </a:r>
-            <a:r>
-              <a:rPr sz="744" b="1" i="0">
-                <a:solidFill>
-                  <a:srgbClr val="111111"/>
-                </a:solidFill>
-                <a:latin typeface="Versos"/>
-              </a:rPr>
-              <a:t>5,5%</a:t>
-            </a:r>
-          </a:p>
-        </p:txBody>
-      </p:sp>
-      <p:sp>
-        <p:nvSpPr>
-          <p:cNvPr id="59" name="TextBox 58"/>
-          <p:cNvSpPr txBox="1"/>
-          <p:nvPr/>
-        </p:nvSpPr>
-        <p:spPr>
-          <a:xfrm>
-            <a:off x="5405636" y="6929566"/>
-            <a:ext cx="688942" cy="113400"/>
-          </a:xfrm>
-          <a:prstGeom prst="rect">
-            <a:avLst/>
-          </a:prstGeom>
-          <a:noFill/>
-        </p:spPr>
-        <p:txBody>
-          <a:bodyPr wrap="none" lIns="0" rIns="0" tIns="0" bIns="0" anchor="t"/>
-          <a:lstStyle/>
-          <a:p>
-            <a:pPr algn="l">
-              <a:lnSpc>
-                <a:spcPts val="892"/>
-              </a:lnSpc>
-            </a:pPr>
-            <a:r>
-              <a:rPr sz="744" b="0" i="0">
-                <a:solidFill>
-                  <a:srgbClr val="333333"/>
-                </a:solidFill>
-                <a:latin typeface="Versos"/>
-              </a:rPr>
-              <a:t>Liquidez </a:t>
-            </a:r>
-            <a:r>
-              <a:rPr sz="744" b="1" i="0">
-                <a:solidFill>
-                  <a:srgbClr val="111111"/>
-                </a:solidFill>
-                <a:latin typeface="Versos"/>
-              </a:rPr>
-              <a:t>5,3%</a:t>
-            </a:r>
-          </a:p>
-        </p:txBody>
-      </p:sp>
-      <p:sp>
-        <p:nvSpPr>
-          <p:cNvPr id="60" name="TextBox 59"/>
-          <p:cNvSpPr txBox="1"/>
-          <p:nvPr/>
-        </p:nvSpPr>
-        <p:spPr>
-          <a:xfrm>
-            <a:off x="529200" y="7088326"/>
-            <a:ext cx="1019532" cy="113400"/>
-          </a:xfrm>
-          <a:prstGeom prst="rect">
-            <a:avLst/>
-          </a:prstGeom>
-          <a:noFill/>
-        </p:spPr>
-        <p:txBody>
-          <a:bodyPr wrap="none" lIns="0" rIns="0" tIns="0" bIns="0" anchor="t"/>
-          <a:lstStyle/>
-          <a:p>
-            <a:pPr algn="l">
-              <a:lnSpc>
-                <a:spcPts val="892"/>
-              </a:lnSpc>
-            </a:pPr>
-            <a:r>
-              <a:rPr sz="744" b="0" i="0">
-                <a:solidFill>
-                  <a:srgbClr val="333333"/>
-                </a:solidFill>
-                <a:latin typeface="Versos"/>
-              </a:rPr>
-              <a:t>Crédito Privado </a:t>
-            </a:r>
-            <a:r>
-              <a:rPr sz="744" b="1" i="0">
-                <a:solidFill>
-                  <a:srgbClr val="111111"/>
-                </a:solidFill>
-                <a:latin typeface="Versos"/>
-              </a:rPr>
-              <a:t>3,4%</a:t>
-            </a:r>
-          </a:p>
-        </p:txBody>
-      </p:sp>
-      <p:sp>
-        <p:nvSpPr>
-          <p:cNvPr id="61" name="TextBox 60"/>
-          <p:cNvSpPr txBox="1"/>
-          <p:nvPr/>
-        </p:nvSpPr>
-        <p:spPr>
-          <a:xfrm>
-            <a:off x="1774119" y="7088326"/>
-            <a:ext cx="776657" cy="113400"/>
-          </a:xfrm>
-          <a:prstGeom prst="rect">
-            <a:avLst/>
-          </a:prstGeom>
-          <a:noFill/>
-        </p:spPr>
-        <p:txBody>
-          <a:bodyPr wrap="none" lIns="0" rIns="0" tIns="0" bIns="0" anchor="t"/>
-          <a:lstStyle/>
-          <a:p>
-            <a:pPr algn="l">
-              <a:lnSpc>
-                <a:spcPts val="892"/>
-              </a:lnSpc>
-            </a:pPr>
-            <a:r>
-              <a:rPr sz="744" b="0" i="0">
-                <a:solidFill>
-                  <a:srgbClr val="333333"/>
-                </a:solidFill>
-                <a:latin typeface="Versos"/>
-              </a:rPr>
-              <a:t>Precatório </a:t>
-            </a:r>
-            <a:r>
-              <a:rPr sz="744" b="1" i="0">
-                <a:solidFill>
-                  <a:srgbClr val="111111"/>
-                </a:solidFill>
-                <a:latin typeface="Versos"/>
-              </a:rPr>
-              <a:t>2,7%</a:t>
-            </a:r>
-          </a:p>
-        </p:txBody>
-      </p:sp>
-      <p:sp>
-        <p:nvSpPr>
-          <p:cNvPr id="62" name="TextBox 61"/>
-          <p:cNvSpPr txBox="1"/>
-          <p:nvPr/>
-        </p:nvSpPr>
-        <p:spPr>
-          <a:xfrm>
-            <a:off x="2785505" y="7088326"/>
-            <a:ext cx="1220637" cy="113400"/>
-          </a:xfrm>
-          <a:prstGeom prst="rect">
-            <a:avLst/>
-          </a:prstGeom>
-          <a:noFill/>
-        </p:spPr>
-        <p:txBody>
-          <a:bodyPr wrap="none" lIns="0" rIns="0" tIns="0" bIns="0" anchor="t"/>
-          <a:lstStyle/>
-          <a:p>
-            <a:pPr algn="l">
-              <a:lnSpc>
-                <a:spcPts val="892"/>
-              </a:lnSpc>
-            </a:pPr>
-            <a:r>
-              <a:rPr sz="744" b="0" i="0">
-                <a:solidFill>
-                  <a:srgbClr val="333333"/>
-                </a:solidFill>
-                <a:latin typeface="Versos"/>
-              </a:rPr>
-              <a:t>Crédito Estruturado </a:t>
-            </a:r>
-            <a:r>
-              <a:rPr sz="744" b="1" i="0">
-                <a:solidFill>
-                  <a:srgbClr val="111111"/>
-                </a:solidFill>
-                <a:latin typeface="Versos"/>
-              </a:rPr>
-              <a:t>2,6%</a:t>
-            </a:r>
-          </a:p>
-        </p:txBody>
-      </p:sp>
-      <p:sp>
-        <p:nvSpPr>
-          <p:cNvPr id="63" name="TextBox 62"/>
+          <p:cNvPr id="64" name="TextBox 63"/>
           <p:cNvSpPr txBox="1"/>
           <p:nvPr/>
         </p:nvSpPr>
@@ -5531,7 +5591,7 @@
       </p:sp>
       <p:sp>
         <p:nvSpPr>
-          <p:cNvPr id="64" name="TextBox 63"/>
+          <p:cNvPr id="65" name="TextBox 64"/>
           <p:cNvSpPr txBox="1"/>
           <p:nvPr/>
         </p:nvSpPr>
@@ -5568,7 +5628,7 @@
       </p:sp>
       <p:sp>
         <p:nvSpPr>
-          <p:cNvPr id="65" name="TextBox 64"/>
+          <p:cNvPr id="66" name="TextBox 65"/>
           <p:cNvSpPr txBox="1"/>
           <p:nvPr/>
         </p:nvSpPr>
@@ -5605,7 +5665,7 @@
       </p:sp>
       <p:sp>
         <p:nvSpPr>
-          <p:cNvPr id="66" name="TextBox 65"/>
+          <p:cNvPr id="67" name="TextBox 66"/>
           <p:cNvSpPr txBox="1"/>
           <p:nvPr/>
         </p:nvSpPr>
@@ -5642,7 +5702,7 @@
       </p:sp>
       <p:sp>
         <p:nvSpPr>
-          <p:cNvPr id="67" name="TextBox 66"/>
+          <p:cNvPr id="68" name="TextBox 67"/>
           <p:cNvSpPr txBox="1"/>
           <p:nvPr/>
         </p:nvSpPr>

</xml_diff>

<commit_message>
AutomaTivio: alocação real com os nomes da gestão; book "Padrão" resolvido pelo tipo do ativo
- Rótulos: FIDCs Cota Sênior, FIDCs Cota Mezanino, Liquidez, Crédito
  Estruturado, Precatório, Fiagro.
- "Padrão" é posição sem book na planilha e nunca aparece: o tipo do ativo
  (Tipo aj.) decide o book (book_sem_book em fundos.yml) — ação ordinária
  vira FIP, LFT/Caixa vira Liquidez, FIDC Sr vira FIDCs Cota Sênior. ALT
  Light passa a fechar com o publicado: Liquidez 7,8% e FIP 1,9%.

Co-Authored-By: Claude Opus 5.5 <noreply@anthropic.com>
</commit_message>
<xml_diff>
--- a/AutomaTivio/saida/2026-08/pptx/Tivio ALT 180 - Relatório de Gestão - Agosto 2026.pptx
+++ b/AutomaTivio/saida/2026-08/pptx/Tivio ALT 180 - Relatório de Gestão - Agosto 2026.pptx
@@ -4680,7 +4680,7 @@
                 </a:solidFill>
                 <a:latin typeface="Versos"/>
               </a:rPr>
-              <a:t>FIDC</a:t>
+              <a:t>FIDCs</a:t>
             </a:r>
           </a:p>
           <a:p>
@@ -4696,7 +4696,7 @@
                 </a:solidFill>
                 <a:latin typeface="Versos"/>
               </a:rPr>
-              <a:t>Sênior</a:t>
+              <a:t>Cota Sênior</a:t>
             </a:r>
           </a:p>
         </p:txBody>
@@ -4770,7 +4770,7 @@
                 </a:solidFill>
                 <a:latin typeface="Versos"/>
               </a:rPr>
-              <a:t>FIDC</a:t>
+              <a:t>FIDCs</a:t>
             </a:r>
           </a:p>
           <a:p>
@@ -4786,7 +4786,7 @@
                 </a:solidFill>
                 <a:latin typeface="Versos"/>
               </a:rPr>
-              <a:t>Mezanino</a:t>
+              <a:t>Cota Mezanino</a:t>
             </a:r>
           </a:p>
         </p:txBody>
@@ -5188,7 +5188,7 @@
                 </a:solidFill>
                 <a:latin typeface="Versos"/>
               </a:rPr>
-              <a:t>Precatórios</a:t>
+              <a:t>Precatório</a:t>
             </a:r>
           </a:p>
         </p:txBody>
@@ -5239,7 +5239,7 @@
         <p:spPr>
           <a:xfrm>
             <a:off x="529200" y="6929566"/>
-            <a:ext cx="938082" cy="113400"/>
+            <a:ext cx="1236116" cy="113400"/>
           </a:xfrm>
           <a:prstGeom prst="rect">
             <a:avLst/>
@@ -5262,7 +5262,7 @@
                 </a:solidFill>
                 <a:latin typeface="Versos"/>
               </a:rPr>
-              <a:t>FIDC Sênior </a:t>
+              <a:t>FIDCs Cota Sênior </a:t>
             </a:r>
             <a:r>
               <a:rPr sz="744" b="1" i="0">
@@ -5284,8 +5284,8 @@
         </p:nvSpPr>
         <p:spPr>
           <a:xfrm>
-            <a:off x="1695802" y="6929566"/>
-            <a:ext cx="1070392" cy="113400"/>
+            <a:off x="1982373" y="6929566"/>
+            <a:ext cx="1368426" cy="113400"/>
           </a:xfrm>
           <a:prstGeom prst="rect">
             <a:avLst/>
@@ -5308,7 +5308,7 @@
                 </a:solidFill>
                 <a:latin typeface="Versos"/>
               </a:rPr>
-              <a:t>FIDC Mezanino </a:t>
+              <a:t>FIDCs Cota Mezanino </a:t>
             </a:r>
             <a:r>
               <a:rPr sz="744" b="1" i="0">
@@ -5330,7 +5330,7 @@
         </p:nvSpPr>
         <p:spPr>
           <a:xfrm>
-            <a:off x="2989625" y="6929566"/>
+            <a:off x="3562768" y="6929566"/>
             <a:ext cx="701350" cy="113400"/>
           </a:xfrm>
           <a:prstGeom prst="rect">
@@ -5376,7 +5376,7 @@
         </p:nvSpPr>
         <p:spPr>
           <a:xfrm>
-            <a:off x="3928601" y="6929566"/>
+            <a:off x="4501743" y="6929566"/>
             <a:ext cx="1217689" cy="113400"/>
           </a:xfrm>
           <a:prstGeom prst="rect">
@@ -5422,7 +5422,7 @@
         </p:nvSpPr>
         <p:spPr>
           <a:xfrm>
-            <a:off x="5364056" y="6929566"/>
+            <a:off x="5937198" y="6929566"/>
             <a:ext cx="1019532" cy="113400"/>
           </a:xfrm>
           <a:prstGeom prst="rect">
@@ -5515,7 +5515,7 @@
         <p:spPr>
           <a:xfrm>
             <a:off x="1356783" y="7088326"/>
-            <a:ext cx="827640" cy="113400"/>
+            <a:ext cx="776657" cy="113400"/>
           </a:xfrm>
           <a:prstGeom prst="rect">
             <a:avLst/>
@@ -5538,7 +5538,7 @@
                 </a:solidFill>
                 <a:latin typeface="Versos"/>
               </a:rPr>
-              <a:t>Precatórios </a:t>
+              <a:t>Precatório </a:t>
             </a:r>
             <a:r>
               <a:rPr sz="744" b="1" i="0">

</xml_diff>

<commit_message>
AutomaTivio: comentário sempre bate com a tabela; treemap com nomes e faixas abaixo de 2%
- engine/sincroniza.py: nas frases-padrão do comentário do gestor, cada
  número é trocado pelo valor da tabela (mês, % do benchmark, ano, desde o
  início, CDI+, anualizado, alocação em crédito, carrego, duration). Vale
  para relatório, post e e-mail, porque roda no Contexto.
- Treemap da alocação real: o nome aparece sempre que for legível (duas
  linhas, ou uma linha com corpo menor); itens abaixo de 2% viram faixa no
  pé do último bloco, com nome e valor numa linha.

Co-Authored-By: Claude Opus 5.5 <noreply@anthropic.com>
</commit_message>
<xml_diff>
--- a/AutomaTivio/saida/2026-08/pptx/Tivio ALT 180 - Relatório de Gestão - Agosto 2026.pptx
+++ b/AutomaTivio/saida/2026-08/pptx/Tivio ALT 180 - Relatório de Gestão - Agosto 2026.pptx
@@ -5000,8 +5000,8 @@
         </p:nvSpPr>
         <p:spPr>
           <a:xfrm>
-            <a:off x="6809670" y="6051898"/>
-            <a:ext cx="311731" cy="142104"/>
+            <a:off x="6809670" y="6065128"/>
+            <a:ext cx="311731" cy="127929"/>
           </a:xfrm>
           <a:prstGeom prst="rect">
             <a:avLst/>
@@ -5014,11 +5014,11 @@
           <a:p>
             <a:pPr algn="l">
               <a:lnSpc>
-                <a:spcPts val="523"/>
-              </a:lnSpc>
-            </a:pPr>
-            <a:r>
-              <a:rPr sz="476" b="0" i="0">
+                <a:spcPts val="471"/>
+              </a:lnSpc>
+            </a:pPr>
+            <a:r>
+              <a:rPr sz="428" b="0" i="0">
                 <a:solidFill>
                   <a:srgbClr val="2B3744"/>
                 </a:solidFill>
@@ -5030,11 +5030,11 @@
           <a:p>
             <a:pPr algn="l">
               <a:lnSpc>
-                <a:spcPts val="523"/>
-              </a:lnSpc>
-            </a:pPr>
-            <a:r>
-              <a:rPr sz="476" b="1" i="0">
+                <a:spcPts val="471"/>
+              </a:lnSpc>
+            </a:pPr>
+            <a:r>
+              <a:rPr sz="428" b="1" i="0">
                 <a:solidFill>
                   <a:srgbClr val="2B3744"/>
                 </a:solidFill>

</xml_diff>